<commit_message>
feat: robots slide in brand template, fix arch stripe overflow
</commit_message>
<xml_diff>
--- a/brand/HEL-brand-template.pptx
+++ b/brand/HEL-brand-template.pptx
@@ -12,6 +12,7 @@
     <p:sldId id="260" r:id="rId11"/>
     <p:sldId id="261" r:id="rId12"/>
     <p:sldId id="262" r:id="rId13"/>
+    <p:sldId id="277" r:id="rId28"/>
     <p:sldId id="263" r:id="rId14"/>
     <p:sldId id="264" r:id="rId15"/>
     <p:sldId id="265" r:id="rId16"/>
@@ -3587,323 +3588,20 @@
               <a:gd name="adj2" fmla="val 0"/>
             </a:avLst>
           </a:prstGeom>
-          <a:solidFill>
-            <a:srgbClr val="FFFFFF"/>
-          </a:solidFill>
+          <a:effectLst/>
+          <a:pattFill prst="ltHorz">
+            <a:fgClr>
+              <a:srgbClr val="16211D"/>
+            </a:fgClr>
+            <a:bgClr>
+              <a:srgbClr val="FFFFFF"/>
+            </a:bgClr>
+          </a:pattFill>
           <a:ln w="31750">
             <a:solidFill>
               <a:srgbClr val="16211D"/>
             </a:solidFill>
           </a:ln>
-          <a:effectLst/>
-        </p:spPr>
-        <p:style>
-          <a:lnRef idx="1">
-            <a:schemeClr val="accent1"/>
-          </a:lnRef>
-          <a:fillRef idx="3">
-            <a:schemeClr val="accent1"/>
-          </a:fillRef>
-          <a:effectRef idx="2">
-            <a:schemeClr val="accent1"/>
-          </a:effectRef>
-          <a:fontRef idx="minor">
-            <a:schemeClr val="lt1"/>
-          </a:fontRef>
-        </p:style>
-        <p:txBody>
-          <a:bodyPr rtlCol="0" anchor="ctr"/>
-          <a:lstStyle/>
-          <a:p>
-            <a:pPr algn="ctr"/>
-          </a:p>
-        </p:txBody>
-      </p:sp>
-      <p:sp>
-        <p:nvSpPr>
-          <p:cNvPr id="12" name="Rectangle 11"/>
-          <p:cNvSpPr/>
-          <p:nvPr/>
-        </p:nvSpPr>
-        <p:spPr>
-          <a:xfrm>
-            <a:off x="9107424" y="3066097"/>
-            <a:ext cx="1691640" cy="20320"/>
-          </a:xfrm>
-          <a:prstGeom prst="rect">
-            <a:avLst/>
-          </a:prstGeom>
-          <a:solidFill>
-            <a:srgbClr val="16211D"/>
-          </a:solidFill>
-          <a:ln>
-            <a:noFill/>
-          </a:ln>
-          <a:effectLst/>
-        </p:spPr>
-        <p:style>
-          <a:lnRef idx="1">
-            <a:schemeClr val="accent1"/>
-          </a:lnRef>
-          <a:fillRef idx="3">
-            <a:schemeClr val="accent1"/>
-          </a:fillRef>
-          <a:effectRef idx="2">
-            <a:schemeClr val="accent1"/>
-          </a:effectRef>
-          <a:fontRef idx="minor">
-            <a:schemeClr val="lt1"/>
-          </a:fontRef>
-        </p:style>
-        <p:txBody>
-          <a:bodyPr rtlCol="0" anchor="ctr"/>
-          <a:lstStyle/>
-          <a:p>
-            <a:pPr algn="ctr"/>
-          </a:p>
-        </p:txBody>
-      </p:sp>
-      <p:sp>
-        <p:nvSpPr>
-          <p:cNvPr id="13" name="Rectangle 12"/>
-          <p:cNvSpPr/>
-          <p:nvPr/>
-        </p:nvSpPr>
-        <p:spPr>
-          <a:xfrm>
-            <a:off x="9107424" y="3366135"/>
-            <a:ext cx="1691640" cy="20320"/>
-          </a:xfrm>
-          <a:prstGeom prst="rect">
-            <a:avLst/>
-          </a:prstGeom>
-          <a:solidFill>
-            <a:srgbClr val="16211D"/>
-          </a:solidFill>
-          <a:ln>
-            <a:noFill/>
-          </a:ln>
-          <a:effectLst/>
-        </p:spPr>
-        <p:style>
-          <a:lnRef idx="1">
-            <a:schemeClr val="accent1"/>
-          </a:lnRef>
-          <a:fillRef idx="3">
-            <a:schemeClr val="accent1"/>
-          </a:fillRef>
-          <a:effectRef idx="2">
-            <a:schemeClr val="accent1"/>
-          </a:effectRef>
-          <a:fontRef idx="minor">
-            <a:schemeClr val="lt1"/>
-          </a:fontRef>
-        </p:style>
-        <p:txBody>
-          <a:bodyPr rtlCol="0" anchor="ctr"/>
-          <a:lstStyle/>
-          <a:p>
-            <a:pPr algn="ctr"/>
-          </a:p>
-        </p:txBody>
-      </p:sp>
-      <p:sp>
-        <p:nvSpPr>
-          <p:cNvPr id="14" name="Rectangle 13"/>
-          <p:cNvSpPr/>
-          <p:nvPr/>
-        </p:nvSpPr>
-        <p:spPr>
-          <a:xfrm>
-            <a:off x="9107424" y="3666172"/>
-            <a:ext cx="1691640" cy="20320"/>
-          </a:xfrm>
-          <a:prstGeom prst="rect">
-            <a:avLst/>
-          </a:prstGeom>
-          <a:solidFill>
-            <a:srgbClr val="16211D"/>
-          </a:solidFill>
-          <a:ln>
-            <a:noFill/>
-          </a:ln>
-          <a:effectLst/>
-        </p:spPr>
-        <p:style>
-          <a:lnRef idx="1">
-            <a:schemeClr val="accent1"/>
-          </a:lnRef>
-          <a:fillRef idx="3">
-            <a:schemeClr val="accent1"/>
-          </a:fillRef>
-          <a:effectRef idx="2">
-            <a:schemeClr val="accent1"/>
-          </a:effectRef>
-          <a:fontRef idx="minor">
-            <a:schemeClr val="lt1"/>
-          </a:fontRef>
-        </p:style>
-        <p:txBody>
-          <a:bodyPr rtlCol="0" anchor="ctr"/>
-          <a:lstStyle/>
-          <a:p>
-            <a:pPr algn="ctr"/>
-          </a:p>
-        </p:txBody>
-      </p:sp>
-      <p:sp>
-        <p:nvSpPr>
-          <p:cNvPr id="15" name="Rectangle 14"/>
-          <p:cNvSpPr/>
-          <p:nvPr/>
-        </p:nvSpPr>
-        <p:spPr>
-          <a:xfrm>
-            <a:off x="9107424" y="3966210"/>
-            <a:ext cx="1691640" cy="20320"/>
-          </a:xfrm>
-          <a:prstGeom prst="rect">
-            <a:avLst/>
-          </a:prstGeom>
-          <a:solidFill>
-            <a:srgbClr val="16211D"/>
-          </a:solidFill>
-          <a:ln>
-            <a:noFill/>
-          </a:ln>
-          <a:effectLst/>
-        </p:spPr>
-        <p:style>
-          <a:lnRef idx="1">
-            <a:schemeClr val="accent1"/>
-          </a:lnRef>
-          <a:fillRef idx="3">
-            <a:schemeClr val="accent1"/>
-          </a:fillRef>
-          <a:effectRef idx="2">
-            <a:schemeClr val="accent1"/>
-          </a:effectRef>
-          <a:fontRef idx="minor">
-            <a:schemeClr val="lt1"/>
-          </a:fontRef>
-        </p:style>
-        <p:txBody>
-          <a:bodyPr rtlCol="0" anchor="ctr"/>
-          <a:lstStyle/>
-          <a:p>
-            <a:pPr algn="ctr"/>
-          </a:p>
-        </p:txBody>
-      </p:sp>
-      <p:sp>
-        <p:nvSpPr>
-          <p:cNvPr id="16" name="Rectangle 15"/>
-          <p:cNvSpPr/>
-          <p:nvPr/>
-        </p:nvSpPr>
-        <p:spPr>
-          <a:xfrm>
-            <a:off x="9107424" y="4266247"/>
-            <a:ext cx="1691640" cy="20320"/>
-          </a:xfrm>
-          <a:prstGeom prst="rect">
-            <a:avLst/>
-          </a:prstGeom>
-          <a:solidFill>
-            <a:srgbClr val="16211D"/>
-          </a:solidFill>
-          <a:ln>
-            <a:noFill/>
-          </a:ln>
-          <a:effectLst/>
-        </p:spPr>
-        <p:style>
-          <a:lnRef idx="1">
-            <a:schemeClr val="accent1"/>
-          </a:lnRef>
-          <a:fillRef idx="3">
-            <a:schemeClr val="accent1"/>
-          </a:fillRef>
-          <a:effectRef idx="2">
-            <a:schemeClr val="accent1"/>
-          </a:effectRef>
-          <a:fontRef idx="minor">
-            <a:schemeClr val="lt1"/>
-          </a:fontRef>
-        </p:style>
-        <p:txBody>
-          <a:bodyPr rtlCol="0" anchor="ctr"/>
-          <a:lstStyle/>
-          <a:p>
-            <a:pPr algn="ctr"/>
-          </a:p>
-        </p:txBody>
-      </p:sp>
-      <p:sp>
-        <p:nvSpPr>
-          <p:cNvPr id="17" name="Rectangle 16"/>
-          <p:cNvSpPr/>
-          <p:nvPr/>
-        </p:nvSpPr>
-        <p:spPr>
-          <a:xfrm>
-            <a:off x="9107424" y="4566285"/>
-            <a:ext cx="1691640" cy="20320"/>
-          </a:xfrm>
-          <a:prstGeom prst="rect">
-            <a:avLst/>
-          </a:prstGeom>
-          <a:solidFill>
-            <a:srgbClr val="16211D"/>
-          </a:solidFill>
-          <a:ln>
-            <a:noFill/>
-          </a:ln>
-          <a:effectLst/>
-        </p:spPr>
-        <p:style>
-          <a:lnRef idx="1">
-            <a:schemeClr val="accent1"/>
-          </a:lnRef>
-          <a:fillRef idx="3">
-            <a:schemeClr val="accent1"/>
-          </a:fillRef>
-          <a:effectRef idx="2">
-            <a:schemeClr val="accent1"/>
-          </a:effectRef>
-          <a:fontRef idx="minor">
-            <a:schemeClr val="lt1"/>
-          </a:fontRef>
-        </p:style>
-        <p:txBody>
-          <a:bodyPr rtlCol="0" anchor="ctr"/>
-          <a:lstStyle/>
-          <a:p>
-            <a:pPr algn="ctr"/>
-          </a:p>
-        </p:txBody>
-      </p:sp>
-      <p:sp>
-        <p:nvSpPr>
-          <p:cNvPr id="18" name="Rectangle 17"/>
-          <p:cNvSpPr/>
-          <p:nvPr/>
-        </p:nvSpPr>
-        <p:spPr>
-          <a:xfrm>
-            <a:off x="9107424" y="4866322"/>
-            <a:ext cx="1691640" cy="20320"/>
-          </a:xfrm>
-          <a:prstGeom prst="rect">
-            <a:avLst/>
-          </a:prstGeom>
-          <a:solidFill>
-            <a:srgbClr val="16211D"/>
-          </a:solidFill>
-          <a:ln>
-            <a:noFill/>
-          </a:ln>
-          <a:effectLst/>
         </p:spPr>
         <p:style>
           <a:lnRef idx="1">
@@ -16200,6 +15898,484 @@
 </p:sld>
 </file>
 
+<file path=ppt/slides/slide22.xml><?xml version="1.0" encoding="utf-8"?>
+<p:sld xmlns:a="http://schemas.openxmlformats.org/drawingml/2006/main" xmlns:p="http://schemas.openxmlformats.org/presentationml/2006/main" xmlns:r="http://schemas.openxmlformats.org/officeDocument/2006/relationships">
+  <p:cSld>
+    <p:spTree>
+      <p:nvGrpSpPr>
+        <p:cNvPr id="1" name=""/>
+        <p:cNvGrpSpPr/>
+        <p:nvPr/>
+      </p:nvGrpSpPr>
+      <p:grpSpPr/>
+      <p:sp>
+        <p:nvSpPr>
+          <p:cNvPr id="2" name="Rectangle 1"/>
+          <p:cNvSpPr/>
+          <p:nvPr/>
+        </p:nvSpPr>
+        <p:spPr>
+          <a:xfrm>
+            <a:off x="0" y="0"/>
+            <a:ext cx="12191695" cy="6858000"/>
+          </a:xfrm>
+          <a:prstGeom prst="rect">
+            <a:avLst/>
+          </a:prstGeom>
+          <a:solidFill>
+            <a:srgbClr val="FBFAF6"/>
+          </a:solidFill>
+          <a:ln>
+            <a:noFill/>
+          </a:ln>
+          <a:effectLst/>
+        </p:spPr>
+        <p:style>
+          <a:lnRef idx="1">
+            <a:schemeClr val="accent1"/>
+          </a:lnRef>
+          <a:fillRef idx="3">
+            <a:schemeClr val="accent1"/>
+          </a:fillRef>
+          <a:effectRef idx="2">
+            <a:schemeClr val="accent1"/>
+          </a:effectRef>
+          <a:fontRef idx="minor">
+            <a:schemeClr val="lt1"/>
+          </a:fontRef>
+        </p:style>
+        <p:txBody>
+          <a:bodyPr rtlCol="0" anchor="ctr"/>
+          <a:lstStyle/>
+          <a:p>
+            <a:pPr algn="ctr"/>
+          </a:p>
+        </p:txBody>
+      </p:sp>
+      <p:sp>
+        <p:nvSpPr>
+          <p:cNvPr id="3" name="TextBox 2"/>
+          <p:cNvSpPr txBox="1"/>
+          <p:nvPr/>
+        </p:nvSpPr>
+        <p:spPr>
+          <a:xfrm>
+            <a:off x="731520" y="457200"/>
+            <a:ext cx="7315200" cy="320040"/>
+          </a:xfrm>
+          <a:prstGeom prst="rect">
+            <a:avLst/>
+          </a:prstGeom>
+          <a:noFill/>
+        </p:spPr>
+        <p:txBody>
+          <a:bodyPr wrap="none">
+            <a:spAutoFit/>
+          </a:bodyPr>
+          <a:lstStyle/>
+          <a:p>
+            <a:r>
+              <a:rPr sz="1050" b="1" spc="160">
+                <a:solidFill>
+                  <a:srgbClr val="17705A"/>
+                </a:solidFill>
+                <a:latin typeface="Space Mono"/>
+              </a:rPr>
+              <a:t>06B · THE ROBOTS</a:t>
+            </a:r>
+          </a:p>
+        </p:txBody>
+      </p:sp>
+      <p:sp>
+        <p:nvSpPr>
+          <p:cNvPr id="4" name="TextBox 3"/>
+          <p:cNvSpPr txBox="1"/>
+          <p:nvPr/>
+        </p:nvSpPr>
+        <p:spPr>
+          <a:xfrm>
+            <a:off x="731520" y="822960"/>
+            <a:ext cx="9144000" cy="640080"/>
+          </a:xfrm>
+          <a:prstGeom prst="rect">
+            <a:avLst/>
+          </a:prstGeom>
+          <a:noFill/>
+        </p:spPr>
+        <p:txBody>
+          <a:bodyPr wrap="none">
+            <a:spAutoFit/>
+          </a:bodyPr>
+          <a:lstStyle/>
+          <a:p>
+            <a:r>
+              <a:rPr sz="3000" b="1">
+                <a:solidFill>
+                  <a:srgbClr val="16211D"/>
+                </a:solidFill>
+                <a:latin typeface="Fraunces"/>
+              </a:rPr>
+              <a:t>Robot friends: six scenes</a:t>
+            </a:r>
+          </a:p>
+        </p:txBody>
+      </p:sp>
+      <p:pic>
+        <p:nvPicPr>
+          <p:cNvPr id="5" name="Picture 4" descr="bot1.png"/>
+          <p:cNvPicPr>
+            <a:picLocks noChangeAspect="1"/>
+          </p:cNvPicPr>
+          <p:nvPr/>
+        </p:nvPicPr>
+        <p:blipFill>
+          <a:blip r:embed="rId2"/>
+          <a:stretch>
+            <a:fillRect/>
+          </a:stretch>
+        </p:blipFill>
+        <p:spPr>
+          <a:xfrm>
+            <a:off x="731520" y="1600200"/>
+            <a:ext cx="2377440" cy="2496312"/>
+          </a:xfrm>
+          <a:prstGeom prst="rect">
+            <a:avLst/>
+          </a:prstGeom>
+        </p:spPr>
+      </p:pic>
+      <p:sp>
+        <p:nvSpPr>
+          <p:cNvPr id="6" name="TextBox 5"/>
+          <p:cNvSpPr txBox="1"/>
+          <p:nvPr/>
+        </p:nvSpPr>
+        <p:spPr>
+          <a:xfrm>
+            <a:off x="731520" y="3986784"/>
+            <a:ext cx="3474720" cy="274320"/>
+          </a:xfrm>
+          <a:prstGeom prst="rect">
+            <a:avLst/>
+          </a:prstGeom>
+          <a:noFill/>
+        </p:spPr>
+        <p:txBody>
+          <a:bodyPr wrap="none">
+            <a:spAutoFit/>
+          </a:bodyPr>
+          <a:lstStyle/>
+          <a:p>
+            <a:r>
+              <a:rPr sz="850" b="1" spc="120">
+                <a:solidFill>
+                  <a:srgbClr val="17705A"/>
+                </a:solidFill>
+                <a:latin typeface="Space Mono"/>
+              </a:rPr>
+              <a:t>Scene 00 · Whole human</a:t>
+            </a:r>
+          </a:p>
+        </p:txBody>
+      </p:sp>
+      <p:pic>
+        <p:nvPicPr>
+          <p:cNvPr id="7" name="Picture 6" descr="bot2.png"/>
+          <p:cNvPicPr>
+            <a:picLocks noChangeAspect="1"/>
+          </p:cNvPicPr>
+          <p:nvPr/>
+        </p:nvPicPr>
+        <p:blipFill>
+          <a:blip r:embed="rId3"/>
+          <a:stretch>
+            <a:fillRect/>
+          </a:stretch>
+        </p:blipFill>
+        <p:spPr>
+          <a:xfrm>
+            <a:off x="4572000" y="1600200"/>
+            <a:ext cx="2377440" cy="2496312"/>
+          </a:xfrm>
+          <a:prstGeom prst="rect">
+            <a:avLst/>
+          </a:prstGeom>
+        </p:spPr>
+      </p:pic>
+      <p:sp>
+        <p:nvSpPr>
+          <p:cNvPr id="8" name="TextBox 7"/>
+          <p:cNvSpPr txBox="1"/>
+          <p:nvPr/>
+        </p:nvSpPr>
+        <p:spPr>
+          <a:xfrm>
+            <a:off x="4572000" y="3986784"/>
+            <a:ext cx="3474720" cy="274320"/>
+          </a:xfrm>
+          <a:prstGeom prst="rect">
+            <a:avLst/>
+          </a:prstGeom>
+          <a:noFill/>
+        </p:spPr>
+        <p:txBody>
+          <a:bodyPr wrap="none">
+            <a:spAutoFit/>
+          </a:bodyPr>
+          <a:lstStyle/>
+          <a:p>
+            <a:r>
+              <a:rPr sz="850" b="1" spc="120">
+                <a:solidFill>
+                  <a:srgbClr val="17705A"/>
+                </a:solidFill>
+                <a:latin typeface="Space Mono"/>
+              </a:rPr>
+              <a:t>Scene 01 · Rolling</a:t>
+            </a:r>
+          </a:p>
+        </p:txBody>
+      </p:sp>
+      <p:pic>
+        <p:nvPicPr>
+          <p:cNvPr id="9" name="Picture 8" descr="bot3.png"/>
+          <p:cNvPicPr>
+            <a:picLocks noChangeAspect="1"/>
+          </p:cNvPicPr>
+          <p:nvPr/>
+        </p:nvPicPr>
+        <p:blipFill>
+          <a:blip r:embed="rId4"/>
+          <a:stretch>
+            <a:fillRect/>
+          </a:stretch>
+        </p:blipFill>
+        <p:spPr>
+          <a:xfrm>
+            <a:off x="8412480" y="1600200"/>
+            <a:ext cx="2377440" cy="2496312"/>
+          </a:xfrm>
+          <a:prstGeom prst="rect">
+            <a:avLst/>
+          </a:prstGeom>
+        </p:spPr>
+      </p:pic>
+      <p:sp>
+        <p:nvSpPr>
+          <p:cNvPr id="10" name="TextBox 9"/>
+          <p:cNvSpPr txBox="1"/>
+          <p:nvPr/>
+        </p:nvSpPr>
+        <p:spPr>
+          <a:xfrm>
+            <a:off x="8412480" y="3986784"/>
+            <a:ext cx="3474720" cy="274320"/>
+          </a:xfrm>
+          <a:prstGeom prst="rect">
+            <a:avLst/>
+          </a:prstGeom>
+          <a:noFill/>
+        </p:spPr>
+        <p:txBody>
+          <a:bodyPr wrap="none">
+            <a:spAutoFit/>
+          </a:bodyPr>
+          <a:lstStyle/>
+          <a:p>
+            <a:r>
+              <a:rPr sz="850" b="1" spc="120">
+                <a:solidFill>
+                  <a:srgbClr val="17705A"/>
+                </a:solidFill>
+                <a:latin typeface="Space Mono"/>
+              </a:rPr>
+              <a:t>Scene 02 · Real conversations</a:t>
+            </a:r>
+          </a:p>
+        </p:txBody>
+      </p:sp>
+      <p:pic>
+        <p:nvPicPr>
+          <p:cNvPr id="11" name="Picture 10" descr="bot4.png"/>
+          <p:cNvPicPr>
+            <a:picLocks noChangeAspect="1"/>
+          </p:cNvPicPr>
+          <p:nvPr/>
+        </p:nvPicPr>
+        <p:blipFill>
+          <a:blip r:embed="rId5"/>
+          <a:stretch>
+            <a:fillRect/>
+          </a:stretch>
+        </p:blipFill>
+        <p:spPr>
+          <a:xfrm>
+            <a:off x="731520" y="4114800"/>
+            <a:ext cx="2377440" cy="2496312"/>
+          </a:xfrm>
+          <a:prstGeom prst="rect">
+            <a:avLst/>
+          </a:prstGeom>
+        </p:spPr>
+      </p:pic>
+      <p:sp>
+        <p:nvSpPr>
+          <p:cNvPr id="12" name="TextBox 11"/>
+          <p:cNvSpPr txBox="1"/>
+          <p:nvPr/>
+        </p:nvSpPr>
+        <p:spPr>
+          <a:xfrm>
+            <a:off x="731520" y="6501384"/>
+            <a:ext cx="3474720" cy="274320"/>
+          </a:xfrm>
+          <a:prstGeom prst="rect">
+            <a:avLst/>
+          </a:prstGeom>
+          <a:noFill/>
+        </p:spPr>
+        <p:txBody>
+          <a:bodyPr wrap="none">
+            <a:spAutoFit/>
+          </a:bodyPr>
+          <a:lstStyle/>
+          <a:p>
+            <a:r>
+              <a:rPr sz="850" b="1" spc="120">
+                <a:solidFill>
+                  <a:srgbClr val="17705A"/>
+                </a:solidFill>
+                <a:latin typeface="Space Mono"/>
+              </a:rPr>
+              <a:t>Scene 03 · Storytelling</a:t>
+            </a:r>
+          </a:p>
+        </p:txBody>
+      </p:sp>
+      <p:pic>
+        <p:nvPicPr>
+          <p:cNvPr id="13" name="Picture 12" descr="bot5.png"/>
+          <p:cNvPicPr>
+            <a:picLocks noChangeAspect="1"/>
+          </p:cNvPicPr>
+          <p:nvPr/>
+        </p:nvPicPr>
+        <p:blipFill>
+          <a:blip r:embed="rId6"/>
+          <a:stretch>
+            <a:fillRect/>
+          </a:stretch>
+        </p:blipFill>
+        <p:spPr>
+          <a:xfrm>
+            <a:off x="4572000" y="4114800"/>
+            <a:ext cx="2377440" cy="2496312"/>
+          </a:xfrm>
+          <a:prstGeom prst="rect">
+            <a:avLst/>
+          </a:prstGeom>
+        </p:spPr>
+      </p:pic>
+      <p:sp>
+        <p:nvSpPr>
+          <p:cNvPr id="14" name="TextBox 13"/>
+          <p:cNvSpPr txBox="1"/>
+          <p:nvPr/>
+        </p:nvSpPr>
+        <p:spPr>
+          <a:xfrm>
+            <a:off x="4572000" y="6501384"/>
+            <a:ext cx="3474720" cy="274320"/>
+          </a:xfrm>
+          <a:prstGeom prst="rect">
+            <a:avLst/>
+          </a:prstGeom>
+          <a:noFill/>
+        </p:spPr>
+        <p:txBody>
+          <a:bodyPr wrap="none">
+            <a:spAutoFit/>
+          </a:bodyPr>
+          <a:lstStyle/>
+          <a:p>
+            <a:r>
+              <a:rPr sz="850" b="1" spc="120">
+                <a:solidFill>
+                  <a:srgbClr val="17705A"/>
+                </a:solidFill>
+                <a:latin typeface="Space Mono"/>
+              </a:rPr>
+              <a:t>Scene 04 · The ensemble</a:t>
+            </a:r>
+          </a:p>
+        </p:txBody>
+      </p:sp>
+      <p:pic>
+        <p:nvPicPr>
+          <p:cNvPr id="15" name="Picture 14" descr="bot6.png"/>
+          <p:cNvPicPr>
+            <a:picLocks noChangeAspect="1"/>
+          </p:cNvPicPr>
+          <p:nvPr/>
+        </p:nvPicPr>
+        <p:blipFill>
+          <a:blip r:embed="rId7"/>
+          <a:stretch>
+            <a:fillRect/>
+          </a:stretch>
+        </p:blipFill>
+        <p:spPr>
+          <a:xfrm>
+            <a:off x="8412480" y="4114800"/>
+            <a:ext cx="2377440" cy="2496312"/>
+          </a:xfrm>
+          <a:prstGeom prst="rect">
+            <a:avLst/>
+          </a:prstGeom>
+        </p:spPr>
+      </p:pic>
+      <p:sp>
+        <p:nvSpPr>
+          <p:cNvPr id="16" name="TextBox 15"/>
+          <p:cNvSpPr txBox="1"/>
+          <p:nvPr/>
+        </p:nvSpPr>
+        <p:spPr>
+          <a:xfrm>
+            <a:off x="8412480" y="6501384"/>
+            <a:ext cx="3474720" cy="274320"/>
+          </a:xfrm>
+          <a:prstGeom prst="rect">
+            <a:avLst/>
+          </a:prstGeom>
+          <a:noFill/>
+        </p:spPr>
+        <p:txBody>
+          <a:bodyPr wrap="none">
+            <a:spAutoFit/>
+          </a:bodyPr>
+          <a:lstStyle/>
+          <a:p>
+            <a:r>
+              <a:rPr sz="850" b="1" spc="120">
+                <a:solidFill>
+                  <a:srgbClr val="17705A"/>
+                </a:solidFill>
+                <a:latin typeface="Space Mono"/>
+              </a:rPr>
+              <a:t>Scene 05 · Zumba o'clock</a:t>
+            </a:r>
+          </a:p>
+        </p:txBody>
+      </p:sp>
+    </p:spTree>
+  </p:cSld>
+  <p:clrMapOvr>
+    <a:masterClrMapping/>
+  </p:clrMapOvr>
+</p:sld>
+</file>
+
 <file path=ppt/slides/slide3.xml><?xml version="1.0" encoding="utf-8"?>
 <p:sld xmlns:a="http://schemas.openxmlformats.org/drawingml/2006/main" xmlns:p="http://schemas.openxmlformats.org/presentationml/2006/main" xmlns:r="http://schemas.openxmlformats.org/officeDocument/2006/relationships">
   <p:cSld>
@@ -18966,323 +19142,20 @@
               <a:gd name="adj2" fmla="val 0"/>
             </a:avLst>
           </a:prstGeom>
-          <a:solidFill>
-            <a:srgbClr val="FFFFFF"/>
-          </a:solidFill>
+          <a:effectLst/>
+          <a:pattFill prst="ltHorz">
+            <a:fgClr>
+              <a:srgbClr val="16211D"/>
+            </a:fgClr>
+            <a:bgClr>
+              <a:srgbClr val="FFFFFF"/>
+            </a:bgClr>
+          </a:pattFill>
           <a:ln w="31750">
             <a:solidFill>
               <a:srgbClr val="16211D"/>
             </a:solidFill>
           </a:ln>
-          <a:effectLst/>
-        </p:spPr>
-        <p:style>
-          <a:lnRef idx="1">
-            <a:schemeClr val="accent1"/>
-          </a:lnRef>
-          <a:fillRef idx="3">
-            <a:schemeClr val="accent1"/>
-          </a:fillRef>
-          <a:effectRef idx="2">
-            <a:schemeClr val="accent1"/>
-          </a:effectRef>
-          <a:fontRef idx="minor">
-            <a:schemeClr val="lt1"/>
-          </a:fontRef>
-        </p:style>
-        <p:txBody>
-          <a:bodyPr rtlCol="0" anchor="ctr"/>
-          <a:lstStyle/>
-          <a:p>
-            <a:pPr algn="ctr"/>
-          </a:p>
-        </p:txBody>
-      </p:sp>
-      <p:sp>
-        <p:nvSpPr>
-          <p:cNvPr id="8" name="Rectangle 7"/>
-          <p:cNvSpPr/>
-          <p:nvPr/>
-        </p:nvSpPr>
-        <p:spPr>
-          <a:xfrm>
-            <a:off x="1152144" y="3180969"/>
-            <a:ext cx="1488643" cy="20320"/>
-          </a:xfrm>
-          <a:prstGeom prst="rect">
-            <a:avLst/>
-          </a:prstGeom>
-          <a:solidFill>
-            <a:srgbClr val="16211D"/>
-          </a:solidFill>
-          <a:ln>
-            <a:noFill/>
-          </a:ln>
-          <a:effectLst/>
-        </p:spPr>
-        <p:style>
-          <a:lnRef idx="1">
-            <a:schemeClr val="accent1"/>
-          </a:lnRef>
-          <a:fillRef idx="3">
-            <a:schemeClr val="accent1"/>
-          </a:fillRef>
-          <a:effectRef idx="2">
-            <a:schemeClr val="accent1"/>
-          </a:effectRef>
-          <a:fontRef idx="minor">
-            <a:schemeClr val="lt1"/>
-          </a:fontRef>
-        </p:style>
-        <p:txBody>
-          <a:bodyPr rtlCol="0" anchor="ctr"/>
-          <a:lstStyle/>
-          <a:p>
-            <a:pPr algn="ctr"/>
-          </a:p>
-        </p:txBody>
-      </p:sp>
-      <p:sp>
-        <p:nvSpPr>
-          <p:cNvPr id="9" name="Rectangle 8"/>
-          <p:cNvSpPr/>
-          <p:nvPr/>
-        </p:nvSpPr>
-        <p:spPr>
-          <a:xfrm>
-            <a:off x="1152144" y="3445002"/>
-            <a:ext cx="1488643" cy="20320"/>
-          </a:xfrm>
-          <a:prstGeom prst="rect">
-            <a:avLst/>
-          </a:prstGeom>
-          <a:solidFill>
-            <a:srgbClr val="16211D"/>
-          </a:solidFill>
-          <a:ln>
-            <a:noFill/>
-          </a:ln>
-          <a:effectLst/>
-        </p:spPr>
-        <p:style>
-          <a:lnRef idx="1">
-            <a:schemeClr val="accent1"/>
-          </a:lnRef>
-          <a:fillRef idx="3">
-            <a:schemeClr val="accent1"/>
-          </a:fillRef>
-          <a:effectRef idx="2">
-            <a:schemeClr val="accent1"/>
-          </a:effectRef>
-          <a:fontRef idx="minor">
-            <a:schemeClr val="lt1"/>
-          </a:fontRef>
-        </p:style>
-        <p:txBody>
-          <a:bodyPr rtlCol="0" anchor="ctr"/>
-          <a:lstStyle/>
-          <a:p>
-            <a:pPr algn="ctr"/>
-          </a:p>
-        </p:txBody>
-      </p:sp>
-      <p:sp>
-        <p:nvSpPr>
-          <p:cNvPr id="10" name="Rectangle 9"/>
-          <p:cNvSpPr/>
-          <p:nvPr/>
-        </p:nvSpPr>
-        <p:spPr>
-          <a:xfrm>
-            <a:off x="1152144" y="3709035"/>
-            <a:ext cx="1488643" cy="20320"/>
-          </a:xfrm>
-          <a:prstGeom prst="rect">
-            <a:avLst/>
-          </a:prstGeom>
-          <a:solidFill>
-            <a:srgbClr val="16211D"/>
-          </a:solidFill>
-          <a:ln>
-            <a:noFill/>
-          </a:ln>
-          <a:effectLst/>
-        </p:spPr>
-        <p:style>
-          <a:lnRef idx="1">
-            <a:schemeClr val="accent1"/>
-          </a:lnRef>
-          <a:fillRef idx="3">
-            <a:schemeClr val="accent1"/>
-          </a:fillRef>
-          <a:effectRef idx="2">
-            <a:schemeClr val="accent1"/>
-          </a:effectRef>
-          <a:fontRef idx="minor">
-            <a:schemeClr val="lt1"/>
-          </a:fontRef>
-        </p:style>
-        <p:txBody>
-          <a:bodyPr rtlCol="0" anchor="ctr"/>
-          <a:lstStyle/>
-          <a:p>
-            <a:pPr algn="ctr"/>
-          </a:p>
-        </p:txBody>
-      </p:sp>
-      <p:sp>
-        <p:nvSpPr>
-          <p:cNvPr id="11" name="Rectangle 10"/>
-          <p:cNvSpPr/>
-          <p:nvPr/>
-        </p:nvSpPr>
-        <p:spPr>
-          <a:xfrm>
-            <a:off x="1152144" y="3973068"/>
-            <a:ext cx="1488643" cy="20320"/>
-          </a:xfrm>
-          <a:prstGeom prst="rect">
-            <a:avLst/>
-          </a:prstGeom>
-          <a:solidFill>
-            <a:srgbClr val="16211D"/>
-          </a:solidFill>
-          <a:ln>
-            <a:noFill/>
-          </a:ln>
-          <a:effectLst/>
-        </p:spPr>
-        <p:style>
-          <a:lnRef idx="1">
-            <a:schemeClr val="accent1"/>
-          </a:lnRef>
-          <a:fillRef idx="3">
-            <a:schemeClr val="accent1"/>
-          </a:fillRef>
-          <a:effectRef idx="2">
-            <a:schemeClr val="accent1"/>
-          </a:effectRef>
-          <a:fontRef idx="minor">
-            <a:schemeClr val="lt1"/>
-          </a:fontRef>
-        </p:style>
-        <p:txBody>
-          <a:bodyPr rtlCol="0" anchor="ctr"/>
-          <a:lstStyle/>
-          <a:p>
-            <a:pPr algn="ctr"/>
-          </a:p>
-        </p:txBody>
-      </p:sp>
-      <p:sp>
-        <p:nvSpPr>
-          <p:cNvPr id="12" name="Rectangle 11"/>
-          <p:cNvSpPr/>
-          <p:nvPr/>
-        </p:nvSpPr>
-        <p:spPr>
-          <a:xfrm>
-            <a:off x="1152144" y="4237101"/>
-            <a:ext cx="1488643" cy="20320"/>
-          </a:xfrm>
-          <a:prstGeom prst="rect">
-            <a:avLst/>
-          </a:prstGeom>
-          <a:solidFill>
-            <a:srgbClr val="16211D"/>
-          </a:solidFill>
-          <a:ln>
-            <a:noFill/>
-          </a:ln>
-          <a:effectLst/>
-        </p:spPr>
-        <p:style>
-          <a:lnRef idx="1">
-            <a:schemeClr val="accent1"/>
-          </a:lnRef>
-          <a:fillRef idx="3">
-            <a:schemeClr val="accent1"/>
-          </a:fillRef>
-          <a:effectRef idx="2">
-            <a:schemeClr val="accent1"/>
-          </a:effectRef>
-          <a:fontRef idx="minor">
-            <a:schemeClr val="lt1"/>
-          </a:fontRef>
-        </p:style>
-        <p:txBody>
-          <a:bodyPr rtlCol="0" anchor="ctr"/>
-          <a:lstStyle/>
-          <a:p>
-            <a:pPr algn="ctr"/>
-          </a:p>
-        </p:txBody>
-      </p:sp>
-      <p:sp>
-        <p:nvSpPr>
-          <p:cNvPr id="13" name="Rectangle 12"/>
-          <p:cNvSpPr/>
-          <p:nvPr/>
-        </p:nvSpPr>
-        <p:spPr>
-          <a:xfrm>
-            <a:off x="1152144" y="4501134"/>
-            <a:ext cx="1488643" cy="20320"/>
-          </a:xfrm>
-          <a:prstGeom prst="rect">
-            <a:avLst/>
-          </a:prstGeom>
-          <a:solidFill>
-            <a:srgbClr val="16211D"/>
-          </a:solidFill>
-          <a:ln>
-            <a:noFill/>
-          </a:ln>
-          <a:effectLst/>
-        </p:spPr>
-        <p:style>
-          <a:lnRef idx="1">
-            <a:schemeClr val="accent1"/>
-          </a:lnRef>
-          <a:fillRef idx="3">
-            <a:schemeClr val="accent1"/>
-          </a:fillRef>
-          <a:effectRef idx="2">
-            <a:schemeClr val="accent1"/>
-          </a:effectRef>
-          <a:fontRef idx="minor">
-            <a:schemeClr val="lt1"/>
-          </a:fontRef>
-        </p:style>
-        <p:txBody>
-          <a:bodyPr rtlCol="0" anchor="ctr"/>
-          <a:lstStyle/>
-          <a:p>
-            <a:pPr algn="ctr"/>
-          </a:p>
-        </p:txBody>
-      </p:sp>
-      <p:sp>
-        <p:nvSpPr>
-          <p:cNvPr id="14" name="Rectangle 13"/>
-          <p:cNvSpPr/>
-          <p:nvPr/>
-        </p:nvSpPr>
-        <p:spPr>
-          <a:xfrm>
-            <a:off x="1152144" y="4765167"/>
-            <a:ext cx="1488643" cy="20320"/>
-          </a:xfrm>
-          <a:prstGeom prst="rect">
-            <a:avLst/>
-          </a:prstGeom>
-          <a:solidFill>
-            <a:srgbClr val="16211D"/>
-          </a:solidFill>
-          <a:ln>
-            <a:noFill/>
-          </a:ln>
-          <a:effectLst/>
         </p:spPr>
         <p:style>
           <a:lnRef idx="1">

</xml_diff>

<commit_message>
fix: arch stripes as scaled tile fill matching robot pattern
</commit_message>
<xml_diff>
--- a/brand/HEL-brand-template.pptx
+++ b/brand/HEL-brand-template.pptx
@@ -3588,14 +3588,10 @@
               <a:gd name="adj2" fmla="val 0"/>
             </a:avLst>
           </a:prstGeom>
-          <a:pattFill prst="ltHorz">
-            <a:fgClr>
-              <a:srgbClr val="16211D"/>
-            </a:fgClr>
-            <a:bgClr>
-              <a:srgbClr val="FFFFFF"/>
-            </a:bgClr>
-          </a:pattFill>
+          <a:blipFill>
+            <a:blip r:embed="rId2"/>
+            <a:tile tx="0" ty="0" sx="100000" sy="100000" flip="none" algn="tl"/>
+          </a:blipFill>
           <a:effectLst/>
           <a:ln w="31750">
             <a:solidFill>
@@ -19119,14 +19115,10 @@
               <a:gd name="adj2" fmla="val 0"/>
             </a:avLst>
           </a:prstGeom>
-          <a:pattFill prst="ltHorz">
-            <a:fgClr>
-              <a:srgbClr val="16211D"/>
-            </a:fgClr>
-            <a:bgClr>
-              <a:srgbClr val="FFFFFF"/>
-            </a:bgClr>
-          </a:pattFill>
+          <a:blipFill>
+            <a:blip r:embed="rId2"/>
+            <a:tile tx="0" ty="0" sx="100000" sy="100000" flip="none" algn="tl"/>
+          </a:blipFill>
           <a:effectLst/>
           <a:ln w="31750">
             <a:solidFill>

</xml_diff>

<commit_message>
feat: robots slide rebuilt as native editable shapes
</commit_message>
<xml_diff>
--- a/brand/HEL-brand-template.pptx
+++ b/brand/HEL-brand-template.pptx
@@ -20332,30 +20332,6 @@
           </a:p>
         </p:txBody>
       </p:sp>
-      <p:pic>
-        <p:nvPicPr>
-          <p:cNvPr id="5" name="Picture 4" descr="bot1.png"/>
-          <p:cNvPicPr>
-            <a:picLocks noChangeAspect="1"/>
-          </p:cNvPicPr>
-          <p:nvPr/>
-        </p:nvPicPr>
-        <p:blipFill>
-          <a:blip r:embed="rId2"/>
-          <a:stretch>
-            <a:fillRect/>
-          </a:stretch>
-        </p:blipFill>
-        <p:spPr>
-          <a:xfrm>
-            <a:off x="731520" y="1600200"/>
-            <a:ext cx="2377440" cy="2496312"/>
-          </a:xfrm>
-          <a:prstGeom prst="rect">
-            <a:avLst/>
-          </a:prstGeom>
-        </p:spPr>
-      </p:pic>
       <p:sp>
         <p:nvSpPr>
           <p:cNvPr id="6" name="TextBox 5"/>
@@ -20390,30 +20366,6 @@
           </a:p>
         </p:txBody>
       </p:sp>
-      <p:pic>
-        <p:nvPicPr>
-          <p:cNvPr id="7" name="Picture 6" descr="bot2.png"/>
-          <p:cNvPicPr>
-            <a:picLocks noChangeAspect="1"/>
-          </p:cNvPicPr>
-          <p:nvPr/>
-        </p:nvPicPr>
-        <p:blipFill>
-          <a:blip r:embed="rId3"/>
-          <a:stretch>
-            <a:fillRect/>
-          </a:stretch>
-        </p:blipFill>
-        <p:spPr>
-          <a:xfrm>
-            <a:off x="4572000" y="1600200"/>
-            <a:ext cx="2377440" cy="2496312"/>
-          </a:xfrm>
-          <a:prstGeom prst="rect">
-            <a:avLst/>
-          </a:prstGeom>
-        </p:spPr>
-      </p:pic>
       <p:sp>
         <p:nvSpPr>
           <p:cNvPr id="8" name="TextBox 7"/>
@@ -20448,30 +20400,6 @@
           </a:p>
         </p:txBody>
       </p:sp>
-      <p:pic>
-        <p:nvPicPr>
-          <p:cNvPr id="9" name="Picture 8" descr="bot3.png"/>
-          <p:cNvPicPr>
-            <a:picLocks noChangeAspect="1"/>
-          </p:cNvPicPr>
-          <p:nvPr/>
-        </p:nvPicPr>
-        <p:blipFill>
-          <a:blip r:embed="rId4"/>
-          <a:stretch>
-            <a:fillRect/>
-          </a:stretch>
-        </p:blipFill>
-        <p:spPr>
-          <a:xfrm>
-            <a:off x="8412480" y="1600200"/>
-            <a:ext cx="2377440" cy="2496312"/>
-          </a:xfrm>
-          <a:prstGeom prst="rect">
-            <a:avLst/>
-          </a:prstGeom>
-        </p:spPr>
-      </p:pic>
       <p:sp>
         <p:nvSpPr>
           <p:cNvPr id="10" name="TextBox 9"/>
@@ -20506,30 +20434,6 @@
           </a:p>
         </p:txBody>
       </p:sp>
-      <p:pic>
-        <p:nvPicPr>
-          <p:cNvPr id="11" name="Picture 10" descr="bot4.png"/>
-          <p:cNvPicPr>
-            <a:picLocks noChangeAspect="1"/>
-          </p:cNvPicPr>
-          <p:nvPr/>
-        </p:nvPicPr>
-        <p:blipFill>
-          <a:blip r:embed="rId5"/>
-          <a:stretch>
-            <a:fillRect/>
-          </a:stretch>
-        </p:blipFill>
-        <p:spPr>
-          <a:xfrm>
-            <a:off x="731520" y="4114800"/>
-            <a:ext cx="2377440" cy="2496312"/>
-          </a:xfrm>
-          <a:prstGeom prst="rect">
-            <a:avLst/>
-          </a:prstGeom>
-        </p:spPr>
-      </p:pic>
       <p:sp>
         <p:nvSpPr>
           <p:cNvPr id="12" name="TextBox 11"/>
@@ -20564,30 +20468,6 @@
           </a:p>
         </p:txBody>
       </p:sp>
-      <p:pic>
-        <p:nvPicPr>
-          <p:cNvPr id="13" name="Picture 12" descr="bot5.png"/>
-          <p:cNvPicPr>
-            <a:picLocks noChangeAspect="1"/>
-          </p:cNvPicPr>
-          <p:nvPr/>
-        </p:nvPicPr>
-        <p:blipFill>
-          <a:blip r:embed="rId6"/>
-          <a:stretch>
-            <a:fillRect/>
-          </a:stretch>
-        </p:blipFill>
-        <p:spPr>
-          <a:xfrm>
-            <a:off x="4572000" y="4114800"/>
-            <a:ext cx="2377440" cy="2496312"/>
-          </a:xfrm>
-          <a:prstGeom prst="rect">
-            <a:avLst/>
-          </a:prstGeom>
-        </p:spPr>
-      </p:pic>
       <p:sp>
         <p:nvSpPr>
           <p:cNvPr id="14" name="TextBox 13"/>
@@ -20622,30 +20502,6 @@
           </a:p>
         </p:txBody>
       </p:sp>
-      <p:pic>
-        <p:nvPicPr>
-          <p:cNvPr id="15" name="Picture 14" descr="bot6.png"/>
-          <p:cNvPicPr>
-            <a:picLocks noChangeAspect="1"/>
-          </p:cNvPicPr>
-          <p:nvPr/>
-        </p:nvPicPr>
-        <p:blipFill>
-          <a:blip r:embed="rId7"/>
-          <a:stretch>
-            <a:fillRect/>
-          </a:stretch>
-        </p:blipFill>
-        <p:spPr>
-          <a:xfrm>
-            <a:off x="8412480" y="4114800"/>
-            <a:ext cx="2377440" cy="2496312"/>
-          </a:xfrm>
-          <a:prstGeom prst="rect">
-            <a:avLst/>
-          </a:prstGeom>
-        </p:spPr>
-      </p:pic>
       <p:sp>
         <p:nvSpPr>
           <p:cNvPr id="16" name="TextBox 15"/>
@@ -20676,6 +20532,3166 @@
                 <a:latin typeface="Space Mono"/>
               </a:rPr>
               <a:t>Scene 05 · Zumba o'clock</a:t>
+            </a:r>
+          </a:p>
+        </p:txBody>
+      </p:sp>
+      <p:sp>
+        <p:nvSpPr>
+          <p:cNvPr id="17" name="Oval 16"/>
+          <p:cNvSpPr/>
+          <p:nvPr/>
+        </p:nvSpPr>
+        <p:spPr>
+          <a:xfrm>
+            <a:off x="1652778" y="1778508"/>
+            <a:ext cx="1129284" cy="1129284"/>
+          </a:xfrm>
+          <a:prstGeom prst="ellipse">
+            <a:avLst/>
+          </a:prstGeom>
+          <a:solidFill>
+            <a:srgbClr val="93D9C2"/>
+          </a:solidFill>
+          <a:ln w="15240">
+            <a:solidFill>
+              <a:srgbClr val="16211D"/>
+            </a:solidFill>
+          </a:ln>
+          <a:effectLst/>
+        </p:spPr>
+        <p:style>
+          <a:lnRef idx="1">
+            <a:schemeClr val="accent1"/>
+          </a:lnRef>
+          <a:fillRef idx="3">
+            <a:schemeClr val="accent1"/>
+          </a:fillRef>
+          <a:effectRef idx="2">
+            <a:schemeClr val="accent1"/>
+          </a:effectRef>
+          <a:fontRef idx="minor">
+            <a:schemeClr val="lt1"/>
+          </a:fontRef>
+        </p:style>
+        <p:txBody>
+          <a:bodyPr rtlCol="0" anchor="ctr"/>
+          <a:lstStyle/>
+          <a:p>
+            <a:pPr algn="ctr"/>
+          </a:p>
+        </p:txBody>
+      </p:sp>
+      <p:sp>
+        <p:nvSpPr>
+          <p:cNvPr id="18" name="Round Same Side Corner Rectangle 17"/>
+          <p:cNvSpPr/>
+          <p:nvPr/>
+        </p:nvSpPr>
+        <p:spPr>
+          <a:xfrm>
+            <a:off x="1147572" y="2848356"/>
+            <a:ext cx="950976" cy="1069848"/>
+          </a:xfrm>
+          <a:prstGeom prst="round2SameRect">
+            <a:avLst>
+              <a:gd name="adj1" fmla="val 100000"/>
+              <a:gd name="adj2" fmla="val 0"/>
+            </a:avLst>
+          </a:prstGeom>
+          <a:blipFill>
+            <a:blip r:embed="rId8"/>
+            <a:tile tx="0" ty="0" sx="100000" sy="100000" flip="none" algn="tl"/>
+          </a:blipFill>
+          <a:ln w="15240">
+            <a:solidFill>
+              <a:srgbClr val="16211D"/>
+            </a:solidFill>
+          </a:ln>
+          <a:effectLst/>
+        </p:spPr>
+        <p:style>
+          <a:lnRef idx="1">
+            <a:schemeClr val="accent1"/>
+          </a:lnRef>
+          <a:fillRef idx="3">
+            <a:schemeClr val="accent1"/>
+          </a:fillRef>
+          <a:effectRef idx="2">
+            <a:schemeClr val="accent1"/>
+          </a:effectRef>
+          <a:fontRef idx="minor">
+            <a:schemeClr val="lt1"/>
+          </a:fontRef>
+        </p:style>
+        <p:txBody>
+          <a:bodyPr rtlCol="0" anchor="ctr"/>
+          <a:lstStyle/>
+          <a:p>
+            <a:pPr algn="ctr"/>
+          </a:p>
+        </p:txBody>
+      </p:sp>
+      <p:sp>
+        <p:nvSpPr>
+          <p:cNvPr id="5" name="Freeform 4"/>
+          <p:cNvSpPr/>
+          <p:nvPr/>
+        </p:nvSpPr>
+        <p:spPr>
+          <a:xfrm>
+            <a:off x="1949958" y="2996946"/>
+            <a:ext cx="950976" cy="921258"/>
+          </a:xfrm>
+          <a:custGeom>
+            <a:avLst/>
+            <a:gdLst/>
+            <a:ahLst/>
+            <a:cxnLst/>
+            <a:rect l="l" t="t" r="r" b="b"/>
+            <a:pathLst>
+              <a:path w="950976" h="921258">
+                <a:moveTo>
+                  <a:pt x="475488" y="0"/>
+                </a:moveTo>
+                <a:lnTo>
+                  <a:pt x="950976" y="921258"/>
+                </a:lnTo>
+                <a:lnTo>
+                  <a:pt x="0" y="921258"/>
+                </a:lnTo>
+                <a:close/>
+              </a:path>
+            </a:pathLst>
+          </a:custGeom>
+          <a:solidFill>
+            <a:srgbClr val="16211D"/>
+          </a:solidFill>
+          <a:ln>
+            <a:noFill/>
+          </a:ln>
+          <a:effectLst/>
+        </p:spPr>
+        <p:style>
+          <a:lnRef idx="1">
+            <a:schemeClr val="accent1"/>
+          </a:lnRef>
+          <a:fillRef idx="3">
+            <a:schemeClr val="accent1"/>
+          </a:fillRef>
+          <a:effectRef idx="2">
+            <a:schemeClr val="accent1"/>
+          </a:effectRef>
+          <a:fontRef idx="minor">
+            <a:schemeClr val="lt1"/>
+          </a:fontRef>
+        </p:style>
+        <p:txBody>
+          <a:bodyPr rtlCol="0" anchor="ctr"/>
+          <a:lstStyle/>
+          <a:p>
+            <a:pPr algn="ctr"/>
+          </a:p>
+        </p:txBody>
+      </p:sp>
+      <p:sp>
+        <p:nvSpPr>
+          <p:cNvPr id="19" name="Rectangle 18"/>
+          <p:cNvSpPr/>
+          <p:nvPr/>
+        </p:nvSpPr>
+        <p:spPr>
+          <a:xfrm rot="21180000">
+            <a:off x="1078880" y="3271771"/>
+            <a:ext cx="1759305" cy="261518"/>
+          </a:xfrm>
+          <a:prstGeom prst="rect">
+            <a:avLst/>
+          </a:prstGeom>
+          <a:solidFill>
+            <a:srgbClr val="16211D"/>
+          </a:solidFill>
+          <a:ln>
+            <a:noFill/>
+          </a:ln>
+          <a:effectLst/>
+        </p:spPr>
+        <p:style>
+          <a:lnRef idx="1">
+            <a:schemeClr val="accent1"/>
+          </a:lnRef>
+          <a:fillRef idx="3">
+            <a:schemeClr val="accent1"/>
+          </a:fillRef>
+          <a:effectRef idx="2">
+            <a:schemeClr val="accent1"/>
+          </a:effectRef>
+          <a:fontRef idx="minor">
+            <a:schemeClr val="lt1"/>
+          </a:fontRef>
+        </p:style>
+        <p:txBody>
+          <a:bodyPr rtlCol="0" anchor="ctr"/>
+          <a:lstStyle/>
+          <a:p>
+            <a:pPr algn="ctr"/>
+          </a:p>
+        </p:txBody>
+      </p:sp>
+      <p:sp>
+        <p:nvSpPr>
+          <p:cNvPr id="20" name="Rectangle 19"/>
+          <p:cNvSpPr/>
+          <p:nvPr/>
+        </p:nvSpPr>
+        <p:spPr>
+          <a:xfrm rot="21180000">
+            <a:off x="1039138" y="3240722"/>
+            <a:ext cx="1759305" cy="261518"/>
+          </a:xfrm>
+          <a:prstGeom prst="rect">
+            <a:avLst/>
+          </a:prstGeom>
+          <a:solidFill>
+            <a:srgbClr val="FFFFFF"/>
+          </a:solidFill>
+          <a:ln w="15240">
+            <a:solidFill>
+              <a:srgbClr val="16211D"/>
+            </a:solidFill>
+          </a:ln>
+          <a:effectLst/>
+        </p:spPr>
+        <p:style>
+          <a:lnRef idx="1">
+            <a:schemeClr val="accent1"/>
+          </a:lnRef>
+          <a:fillRef idx="3">
+            <a:schemeClr val="accent1"/>
+          </a:fillRef>
+          <a:effectRef idx="2">
+            <a:schemeClr val="accent1"/>
+          </a:effectRef>
+          <a:fontRef idx="minor">
+            <a:schemeClr val="lt1"/>
+          </a:fontRef>
+        </p:style>
+        <p:txBody>
+          <a:bodyPr rtlCol="0" anchor="ctr" wrap="none" lIns="0" rIns="0" tIns="0" bIns="0"/>
+          <a:lstStyle/>
+          <a:p>
+            <a:pPr algn="ctr"/>
+            <a:r>
+              <a:rPr sz="700" b="1" spc="60">
+                <a:solidFill>
+                  <a:srgbClr val="16211D"/>
+                </a:solidFill>
+                <a:latin typeface="Space Mono"/>
+              </a:rPr>
+              <a:t>ADMIT ONE · WHOLE HUMAN</a:t>
+            </a:r>
+          </a:p>
+        </p:txBody>
+      </p:sp>
+      <p:sp>
+        <p:nvSpPr>
+          <p:cNvPr id="21" name="Oval 20"/>
+          <p:cNvSpPr/>
+          <p:nvPr/>
+        </p:nvSpPr>
+        <p:spPr>
+          <a:xfrm>
+            <a:off x="6069787" y="1998421"/>
+            <a:ext cx="570585" cy="570585"/>
+          </a:xfrm>
+          <a:prstGeom prst="ellipse">
+            <a:avLst/>
+          </a:prstGeom>
+          <a:solidFill>
+            <a:srgbClr val="93D9C2"/>
+          </a:solidFill>
+          <a:ln w="15240">
+            <a:solidFill>
+              <a:srgbClr val="16211D"/>
+            </a:solidFill>
+          </a:ln>
+          <a:effectLst/>
+        </p:spPr>
+        <p:style>
+          <a:lnRef idx="1">
+            <a:schemeClr val="accent1"/>
+          </a:lnRef>
+          <a:fillRef idx="3">
+            <a:schemeClr val="accent1"/>
+          </a:fillRef>
+          <a:effectRef idx="2">
+            <a:schemeClr val="accent1"/>
+          </a:effectRef>
+          <a:fontRef idx="minor">
+            <a:schemeClr val="lt1"/>
+          </a:fontRef>
+        </p:style>
+        <p:txBody>
+          <a:bodyPr rtlCol="0" anchor="ctr"/>
+          <a:lstStyle/>
+          <a:p>
+            <a:pPr algn="ctr"/>
+          </a:p>
+        </p:txBody>
+      </p:sp>
+      <p:sp>
+        <p:nvSpPr>
+          <p:cNvPr id="22" name="Round Same Side Corner Rectangle 21"/>
+          <p:cNvSpPr/>
+          <p:nvPr/>
+        </p:nvSpPr>
+        <p:spPr>
+          <a:xfrm>
+            <a:off x="6069787" y="2681935"/>
+            <a:ext cx="570585" cy="939088"/>
+          </a:xfrm>
+          <a:prstGeom prst="round2SameRect">
+            <a:avLst>
+              <a:gd name="adj1" fmla="val 100000"/>
+              <a:gd name="adj2" fmla="val 0"/>
+            </a:avLst>
+          </a:prstGeom>
+          <a:blipFill>
+            <a:blip r:embed="rId8"/>
+            <a:tile tx="0" ty="0" sx="100000" sy="100000" flip="none" algn="tl"/>
+          </a:blipFill>
+          <a:ln w="15240">
+            <a:solidFill>
+              <a:srgbClr val="16211D"/>
+            </a:solidFill>
+          </a:ln>
+          <a:effectLst/>
+        </p:spPr>
+        <p:style>
+          <a:lnRef idx="1">
+            <a:schemeClr val="accent1"/>
+          </a:lnRef>
+          <a:fillRef idx="3">
+            <a:schemeClr val="accent1"/>
+          </a:fillRef>
+          <a:effectRef idx="2">
+            <a:schemeClr val="accent1"/>
+          </a:effectRef>
+          <a:fontRef idx="minor">
+            <a:schemeClr val="lt1"/>
+          </a:fontRef>
+        </p:style>
+        <p:txBody>
+          <a:bodyPr rtlCol="0" anchor="ctr"/>
+          <a:lstStyle/>
+          <a:p>
+            <a:pPr algn="ctr"/>
+          </a:p>
+        </p:txBody>
+      </p:sp>
+      <p:cxnSp>
+        <p:nvCxnSpPr>
+          <p:cNvPr id="23" name="Connector 22"/>
+          <p:cNvCxnSpPr/>
+          <p:nvPr/>
+        </p:nvCxnSpPr>
+        <p:spPr>
+          <a:xfrm flipH="1" flipV="1">
+            <a:off x="5790438" y="2937510"/>
+            <a:ext cx="303123" cy="178308"/>
+          </a:xfrm>
+          <a:prstGeom prst="line">
+            <a:avLst/>
+          </a:prstGeom>
+          <a:ln w="35661" cap="rnd">
+            <a:solidFill>
+              <a:srgbClr val="16211D"/>
+            </a:solidFill>
+            <a:round/>
+          </a:ln>
+          <a:effectLst/>
+        </p:spPr>
+        <p:style>
+          <a:lnRef idx="2">
+            <a:schemeClr val="accent1"/>
+          </a:lnRef>
+          <a:fillRef idx="0">
+            <a:schemeClr val="accent1"/>
+          </a:fillRef>
+          <a:effectRef idx="1">
+            <a:schemeClr val="accent1"/>
+          </a:effectRef>
+          <a:fontRef idx="minor">
+            <a:schemeClr val="tx1"/>
+          </a:fontRef>
+        </p:style>
+      </p:cxnSp>
+      <p:sp>
+        <p:nvSpPr>
+          <p:cNvPr id="24" name="Rounded Rectangle 23"/>
+          <p:cNvSpPr/>
+          <p:nvPr/>
+        </p:nvSpPr>
+        <p:spPr>
+          <a:xfrm>
+            <a:off x="5077206" y="2699766"/>
+            <a:ext cx="713232" cy="463600"/>
+          </a:xfrm>
+          <a:prstGeom prst="roundRect">
+            <a:avLst>
+              <a:gd name="adj" fmla="val 12820"/>
+            </a:avLst>
+          </a:prstGeom>
+          <a:solidFill>
+            <a:srgbClr val="16211D"/>
+          </a:solidFill>
+          <a:ln>
+            <a:noFill/>
+          </a:ln>
+          <a:effectLst/>
+        </p:spPr>
+        <p:style>
+          <a:lnRef idx="1">
+            <a:schemeClr val="accent1"/>
+          </a:lnRef>
+          <a:fillRef idx="3">
+            <a:schemeClr val="accent1"/>
+          </a:fillRef>
+          <a:effectRef idx="2">
+            <a:schemeClr val="accent1"/>
+          </a:effectRef>
+          <a:fontRef idx="minor">
+            <a:schemeClr val="lt1"/>
+          </a:fontRef>
+        </p:style>
+        <p:txBody>
+          <a:bodyPr rtlCol="0" anchor="ctr"/>
+          <a:lstStyle/>
+          <a:p>
+            <a:pPr algn="ctr"/>
+          </a:p>
+        </p:txBody>
+      </p:sp>
+      <p:sp>
+        <p:nvSpPr>
+          <p:cNvPr id="25" name="Oval 24"/>
+          <p:cNvSpPr/>
+          <p:nvPr/>
+        </p:nvSpPr>
+        <p:spPr>
+          <a:xfrm>
+            <a:off x="5142585" y="2777032"/>
+            <a:ext cx="309067" cy="309067"/>
+          </a:xfrm>
+          <a:prstGeom prst="ellipse">
+            <a:avLst/>
+          </a:prstGeom>
+          <a:solidFill>
+            <a:srgbClr val="93D9C2"/>
+          </a:solidFill>
+          <a:ln w="15240">
+            <a:solidFill>
+              <a:srgbClr val="16211D"/>
+            </a:solidFill>
+          </a:ln>
+          <a:effectLst/>
+        </p:spPr>
+        <p:style>
+          <a:lnRef idx="1">
+            <a:schemeClr val="accent1"/>
+          </a:lnRef>
+          <a:fillRef idx="3">
+            <a:schemeClr val="accent1"/>
+          </a:fillRef>
+          <a:effectRef idx="2">
+            <a:schemeClr val="accent1"/>
+          </a:effectRef>
+          <a:fontRef idx="minor">
+            <a:schemeClr val="lt1"/>
+          </a:fontRef>
+        </p:style>
+        <p:txBody>
+          <a:bodyPr rtlCol="0" anchor="ctr"/>
+          <a:lstStyle/>
+          <a:p>
+            <a:pPr algn="ctr"/>
+          </a:p>
+        </p:txBody>
+      </p:sp>
+      <p:sp>
+        <p:nvSpPr>
+          <p:cNvPr id="26" name="Oval 25"/>
+          <p:cNvSpPr/>
+          <p:nvPr/>
+        </p:nvSpPr>
+        <p:spPr>
+          <a:xfrm>
+            <a:off x="5237683" y="2872130"/>
+            <a:ext cx="118872" cy="118872"/>
+          </a:xfrm>
+          <a:prstGeom prst="ellipse">
+            <a:avLst/>
+          </a:prstGeom>
+          <a:solidFill>
+            <a:srgbClr val="16211D"/>
+          </a:solidFill>
+          <a:ln>
+            <a:noFill/>
+          </a:ln>
+          <a:effectLst/>
+        </p:spPr>
+        <p:style>
+          <a:lnRef idx="1">
+            <a:schemeClr val="accent1"/>
+          </a:lnRef>
+          <a:fillRef idx="3">
+            <a:schemeClr val="accent1"/>
+          </a:fillRef>
+          <a:effectRef idx="2">
+            <a:schemeClr val="accent1"/>
+          </a:effectRef>
+          <a:fontRef idx="minor">
+            <a:schemeClr val="lt1"/>
+          </a:fontRef>
+        </p:style>
+        <p:txBody>
+          <a:bodyPr rtlCol="0" anchor="ctr"/>
+          <a:lstStyle/>
+          <a:p>
+            <a:pPr algn="ctr"/>
+          </a:p>
+        </p:txBody>
+      </p:sp>
+      <p:sp>
+        <p:nvSpPr>
+          <p:cNvPr id="27" name="Oval 26"/>
+          <p:cNvSpPr/>
+          <p:nvPr/>
+        </p:nvSpPr>
+        <p:spPr>
+          <a:xfrm>
+            <a:off x="5095036" y="2450134"/>
+            <a:ext cx="261518" cy="261518"/>
+          </a:xfrm>
+          <a:prstGeom prst="ellipse">
+            <a:avLst/>
+          </a:prstGeom>
+          <a:solidFill>
+            <a:srgbClr val="FFFFFF"/>
+          </a:solidFill>
+          <a:ln w="15240">
+            <a:solidFill>
+              <a:srgbClr val="16211D"/>
+            </a:solidFill>
+          </a:ln>
+          <a:effectLst/>
+        </p:spPr>
+        <p:style>
+          <a:lnRef idx="1">
+            <a:schemeClr val="accent1"/>
+          </a:lnRef>
+          <a:fillRef idx="3">
+            <a:schemeClr val="accent1"/>
+          </a:fillRef>
+          <a:effectRef idx="2">
+            <a:schemeClr val="accent1"/>
+          </a:effectRef>
+          <a:fontRef idx="minor">
+            <a:schemeClr val="lt1"/>
+          </a:fontRef>
+        </p:style>
+        <p:txBody>
+          <a:bodyPr rtlCol="0" anchor="ctr"/>
+          <a:lstStyle/>
+          <a:p>
+            <a:pPr algn="ctr"/>
+          </a:p>
+        </p:txBody>
+      </p:sp>
+      <p:sp>
+        <p:nvSpPr>
+          <p:cNvPr id="28" name="Oval 27"/>
+          <p:cNvSpPr/>
+          <p:nvPr/>
+        </p:nvSpPr>
+        <p:spPr>
+          <a:xfrm>
+            <a:off x="5392216" y="2450134"/>
+            <a:ext cx="261518" cy="261518"/>
+          </a:xfrm>
+          <a:prstGeom prst="ellipse">
+            <a:avLst/>
+          </a:prstGeom>
+          <a:solidFill>
+            <a:srgbClr val="93D9C2"/>
+          </a:solidFill>
+          <a:ln w="15240">
+            <a:solidFill>
+              <a:srgbClr val="16211D"/>
+            </a:solidFill>
+          </a:ln>
+          <a:effectLst/>
+        </p:spPr>
+        <p:style>
+          <a:lnRef idx="1">
+            <a:schemeClr val="accent1"/>
+          </a:lnRef>
+          <a:fillRef idx="3">
+            <a:schemeClr val="accent1"/>
+          </a:fillRef>
+          <a:effectRef idx="2">
+            <a:schemeClr val="accent1"/>
+          </a:effectRef>
+          <a:fontRef idx="minor">
+            <a:schemeClr val="lt1"/>
+          </a:fontRef>
+        </p:style>
+        <p:txBody>
+          <a:bodyPr rtlCol="0" anchor="ctr"/>
+          <a:lstStyle/>
+          <a:p>
+            <a:pPr algn="ctr"/>
+          </a:p>
+        </p:txBody>
+      </p:sp>
+      <p:cxnSp>
+        <p:nvCxnSpPr>
+          <p:cNvPr id="29" name="Connector 28"/>
+          <p:cNvCxnSpPr/>
+          <p:nvPr/>
+        </p:nvCxnSpPr>
+        <p:spPr>
+          <a:xfrm flipH="1">
+            <a:off x="5136642" y="3163366"/>
+            <a:ext cx="148590" cy="665684"/>
+          </a:xfrm>
+          <a:prstGeom prst="line">
+            <a:avLst/>
+          </a:prstGeom>
+          <a:ln w="35661" cap="rnd">
+            <a:solidFill>
+              <a:srgbClr val="16211D"/>
+            </a:solidFill>
+            <a:round/>
+          </a:ln>
+          <a:effectLst/>
+        </p:spPr>
+        <p:style>
+          <a:lnRef idx="2">
+            <a:schemeClr val="accent1"/>
+          </a:lnRef>
+          <a:fillRef idx="0">
+            <a:schemeClr val="accent1"/>
+          </a:fillRef>
+          <a:effectRef idx="1">
+            <a:schemeClr val="accent1"/>
+          </a:effectRef>
+          <a:fontRef idx="minor">
+            <a:schemeClr val="tx1"/>
+          </a:fontRef>
+        </p:style>
+      </p:cxnSp>
+      <p:cxnSp>
+        <p:nvCxnSpPr>
+          <p:cNvPr id="30" name="Connector 29"/>
+          <p:cNvCxnSpPr/>
+          <p:nvPr/>
+        </p:nvCxnSpPr>
+        <p:spPr>
+          <a:xfrm>
+            <a:off x="5582412" y="3163366"/>
+            <a:ext cx="148590" cy="665684"/>
+          </a:xfrm>
+          <a:prstGeom prst="line">
+            <a:avLst/>
+          </a:prstGeom>
+          <a:ln w="35661" cap="rnd">
+            <a:solidFill>
+              <a:srgbClr val="16211D"/>
+            </a:solidFill>
+            <a:round/>
+          </a:ln>
+          <a:effectLst/>
+        </p:spPr>
+        <p:style>
+          <a:lnRef idx="2">
+            <a:schemeClr val="accent1"/>
+          </a:lnRef>
+          <a:fillRef idx="0">
+            <a:schemeClr val="accent1"/>
+          </a:fillRef>
+          <a:effectRef idx="1">
+            <a:schemeClr val="accent1"/>
+          </a:effectRef>
+          <a:fontRef idx="minor">
+            <a:schemeClr val="tx1"/>
+          </a:fontRef>
+        </p:style>
+      </p:cxnSp>
+      <p:sp>
+        <p:nvSpPr>
+          <p:cNvPr id="31" name="Rectangle 30"/>
+          <p:cNvSpPr/>
+          <p:nvPr/>
+        </p:nvSpPr>
+        <p:spPr>
+          <a:xfrm rot="21240000">
+            <a:off x="5206240" y="3689634"/>
+            <a:ext cx="1164945" cy="237744"/>
+          </a:xfrm>
+          <a:prstGeom prst="rect">
+            <a:avLst/>
+          </a:prstGeom>
+          <a:solidFill>
+            <a:srgbClr val="16211D"/>
+          </a:solidFill>
+          <a:ln>
+            <a:noFill/>
+          </a:ln>
+          <a:effectLst/>
+        </p:spPr>
+        <p:style>
+          <a:lnRef idx="1">
+            <a:schemeClr val="accent1"/>
+          </a:lnRef>
+          <a:fillRef idx="3">
+            <a:schemeClr val="accent1"/>
+          </a:fillRef>
+          <a:effectRef idx="2">
+            <a:schemeClr val="accent1"/>
+          </a:effectRef>
+          <a:fontRef idx="minor">
+            <a:schemeClr val="lt1"/>
+          </a:fontRef>
+        </p:style>
+        <p:txBody>
+          <a:bodyPr rtlCol="0" anchor="ctr"/>
+          <a:lstStyle/>
+          <a:p>
+            <a:pPr algn="ctr"/>
+          </a:p>
+        </p:txBody>
+      </p:sp>
+      <p:sp>
+        <p:nvSpPr>
+          <p:cNvPr id="32" name="Rectangle 31"/>
+          <p:cNvSpPr/>
+          <p:nvPr/>
+        </p:nvSpPr>
+        <p:spPr>
+          <a:xfrm rot="21240000">
+            <a:off x="5167046" y="3657895"/>
+            <a:ext cx="1164945" cy="237744"/>
+          </a:xfrm>
+          <a:prstGeom prst="rect">
+            <a:avLst/>
+          </a:prstGeom>
+          <a:solidFill>
+            <a:srgbClr val="FFFFFF"/>
+          </a:solidFill>
+          <a:ln w="15240">
+            <a:solidFill>
+              <a:srgbClr val="16211D"/>
+            </a:solidFill>
+          </a:ln>
+          <a:effectLst/>
+        </p:spPr>
+        <p:style>
+          <a:lnRef idx="1">
+            <a:schemeClr val="accent1"/>
+          </a:lnRef>
+          <a:fillRef idx="3">
+            <a:schemeClr val="accent1"/>
+          </a:fillRef>
+          <a:effectRef idx="2">
+            <a:schemeClr val="accent1"/>
+          </a:effectRef>
+          <a:fontRef idx="minor">
+            <a:schemeClr val="lt1"/>
+          </a:fontRef>
+        </p:style>
+        <p:txBody>
+          <a:bodyPr rtlCol="0" anchor="ctr" wrap="none" lIns="0" rIns="0" tIns="0" bIns="0"/>
+          <a:lstStyle/>
+          <a:p>
+            <a:pPr algn="ctr"/>
+            <a:r>
+              <a:rPr sz="600" b="1" spc="60">
+                <a:solidFill>
+                  <a:srgbClr val="16211D"/>
+                </a:solidFill>
+                <a:latin typeface="Space Mono"/>
+              </a:rPr>
+              <a:t>SCENE 01 · ROLLING</a:t>
+            </a:r>
+          </a:p>
+        </p:txBody>
+      </p:sp>
+      <p:sp>
+        <p:nvSpPr>
+          <p:cNvPr id="33" name="Oval 32"/>
+          <p:cNvSpPr/>
+          <p:nvPr/>
+        </p:nvSpPr>
+        <p:spPr>
+          <a:xfrm>
+            <a:off x="8816644" y="2331262"/>
+            <a:ext cx="499262" cy="499262"/>
+          </a:xfrm>
+          <a:prstGeom prst="ellipse">
+            <a:avLst/>
+          </a:prstGeom>
+          <a:solidFill>
+            <a:srgbClr val="93D9C2"/>
+          </a:solidFill>
+          <a:ln w="15240">
+            <a:solidFill>
+              <a:srgbClr val="16211D"/>
+            </a:solidFill>
+          </a:ln>
+          <a:effectLst/>
+        </p:spPr>
+        <p:style>
+          <a:lnRef idx="1">
+            <a:schemeClr val="accent1"/>
+          </a:lnRef>
+          <a:fillRef idx="3">
+            <a:schemeClr val="accent1"/>
+          </a:fillRef>
+          <a:effectRef idx="2">
+            <a:schemeClr val="accent1"/>
+          </a:effectRef>
+          <a:fontRef idx="minor">
+            <a:schemeClr val="lt1"/>
+          </a:fontRef>
+        </p:style>
+        <p:txBody>
+          <a:bodyPr rtlCol="0" anchor="ctr"/>
+          <a:lstStyle/>
+          <a:p>
+            <a:pPr algn="ctr"/>
+          </a:p>
+        </p:txBody>
+      </p:sp>
+      <p:sp>
+        <p:nvSpPr>
+          <p:cNvPr id="34" name="Round Same Side Corner Rectangle 33"/>
+          <p:cNvSpPr/>
+          <p:nvPr/>
+        </p:nvSpPr>
+        <p:spPr>
+          <a:xfrm>
+            <a:off x="8816644" y="2866186"/>
+            <a:ext cx="499262" cy="933145"/>
+          </a:xfrm>
+          <a:prstGeom prst="round2SameRect">
+            <a:avLst>
+              <a:gd name="adj1" fmla="val 100000"/>
+              <a:gd name="adj2" fmla="val 0"/>
+            </a:avLst>
+          </a:prstGeom>
+          <a:blipFill>
+            <a:blip r:embed="rId8"/>
+            <a:tile tx="0" ty="0" sx="100000" sy="100000" flip="none" algn="tl"/>
+          </a:blipFill>
+          <a:ln w="15240">
+            <a:solidFill>
+              <a:srgbClr val="16211D"/>
+            </a:solidFill>
+          </a:ln>
+          <a:effectLst/>
+        </p:spPr>
+        <p:style>
+          <a:lnRef idx="1">
+            <a:schemeClr val="accent1"/>
+          </a:lnRef>
+          <a:fillRef idx="3">
+            <a:schemeClr val="accent1"/>
+          </a:fillRef>
+          <a:effectRef idx="2">
+            <a:schemeClr val="accent1"/>
+          </a:effectRef>
+          <a:fontRef idx="minor">
+            <a:schemeClr val="lt1"/>
+          </a:fontRef>
+        </p:style>
+        <p:txBody>
+          <a:bodyPr rtlCol="0" anchor="ctr"/>
+          <a:lstStyle/>
+          <a:p>
+            <a:pPr algn="ctr"/>
+          </a:p>
+        </p:txBody>
+      </p:sp>
+      <p:sp>
+        <p:nvSpPr>
+          <p:cNvPr id="35" name="Oval 34"/>
+          <p:cNvSpPr/>
+          <p:nvPr/>
+        </p:nvSpPr>
+        <p:spPr>
+          <a:xfrm>
+            <a:off x="9969703" y="2444191"/>
+            <a:ext cx="451713" cy="451713"/>
+          </a:xfrm>
+          <a:prstGeom prst="ellipse">
+            <a:avLst/>
+          </a:prstGeom>
+          <a:solidFill>
+            <a:srgbClr val="FFFFFF"/>
+          </a:solidFill>
+          <a:ln w="15240">
+            <a:solidFill>
+              <a:srgbClr val="16211D"/>
+            </a:solidFill>
+          </a:ln>
+          <a:effectLst/>
+        </p:spPr>
+        <p:style>
+          <a:lnRef idx="1">
+            <a:schemeClr val="accent1"/>
+          </a:lnRef>
+          <a:fillRef idx="3">
+            <a:schemeClr val="accent1"/>
+          </a:fillRef>
+          <a:effectRef idx="2">
+            <a:schemeClr val="accent1"/>
+          </a:effectRef>
+          <a:fontRef idx="minor">
+            <a:schemeClr val="lt1"/>
+          </a:fontRef>
+        </p:style>
+        <p:txBody>
+          <a:bodyPr rtlCol="0" anchor="ctr"/>
+          <a:lstStyle/>
+          <a:p>
+            <a:pPr algn="ctr"/>
+          </a:p>
+        </p:txBody>
+      </p:sp>
+      <p:sp>
+        <p:nvSpPr>
+          <p:cNvPr id="7" name="Freeform 6"/>
+          <p:cNvSpPr/>
+          <p:nvPr/>
+        </p:nvSpPr>
+        <p:spPr>
+          <a:xfrm>
+            <a:off x="9809226" y="2979115"/>
+            <a:ext cx="772668" cy="820217"/>
+          </a:xfrm>
+          <a:custGeom>
+            <a:avLst/>
+            <a:gdLst/>
+            <a:ahLst/>
+            <a:cxnLst/>
+            <a:rect l="l" t="t" r="r" b="b"/>
+            <a:pathLst>
+              <a:path w="772668" h="820217">
+                <a:moveTo>
+                  <a:pt x="386334" y="0"/>
+                </a:moveTo>
+                <a:lnTo>
+                  <a:pt x="772668" y="820217"/>
+                </a:lnTo>
+                <a:lnTo>
+                  <a:pt x="0" y="820217"/>
+                </a:lnTo>
+                <a:close/>
+              </a:path>
+            </a:pathLst>
+          </a:custGeom>
+          <a:solidFill>
+            <a:srgbClr val="16211D"/>
+          </a:solidFill>
+          <a:ln>
+            <a:noFill/>
+          </a:ln>
+          <a:effectLst/>
+        </p:spPr>
+        <p:style>
+          <a:lnRef idx="1">
+            <a:schemeClr val="accent1"/>
+          </a:lnRef>
+          <a:fillRef idx="3">
+            <a:schemeClr val="accent1"/>
+          </a:fillRef>
+          <a:effectRef idx="2">
+            <a:schemeClr val="accent1"/>
+          </a:effectRef>
+          <a:fontRef idx="minor">
+            <a:schemeClr val="lt1"/>
+          </a:fontRef>
+        </p:style>
+        <p:txBody>
+          <a:bodyPr rtlCol="0" anchor="ctr"/>
+          <a:lstStyle/>
+          <a:p>
+            <a:pPr algn="ctr"/>
+          </a:p>
+        </p:txBody>
+      </p:sp>
+      <p:sp>
+        <p:nvSpPr>
+          <p:cNvPr id="36" name="Rounded Rectangle 35"/>
+          <p:cNvSpPr/>
+          <p:nvPr/>
+        </p:nvSpPr>
+        <p:spPr>
+          <a:xfrm>
+            <a:off x="9214866" y="1909267"/>
+            <a:ext cx="618134" cy="297180"/>
+          </a:xfrm>
+          <a:prstGeom prst="roundRect">
+            <a:avLst>
+              <a:gd name="adj" fmla="val 50000"/>
+            </a:avLst>
+          </a:prstGeom>
+          <a:solidFill>
+            <a:srgbClr val="93D9C2"/>
+          </a:solidFill>
+          <a:ln w="15240">
+            <a:solidFill>
+              <a:srgbClr val="16211D"/>
+            </a:solidFill>
+          </a:ln>
+          <a:effectLst/>
+        </p:spPr>
+        <p:style>
+          <a:lnRef idx="1">
+            <a:schemeClr val="accent1"/>
+          </a:lnRef>
+          <a:fillRef idx="3">
+            <a:schemeClr val="accent1"/>
+          </a:fillRef>
+          <a:effectRef idx="2">
+            <a:schemeClr val="accent1"/>
+          </a:effectRef>
+          <a:fontRef idx="minor">
+            <a:schemeClr val="lt1"/>
+          </a:fontRef>
+        </p:style>
+        <p:txBody>
+          <a:bodyPr rtlCol="0" anchor="ctr"/>
+          <a:lstStyle/>
+          <a:p>
+            <a:pPr algn="ctr"/>
+          </a:p>
+        </p:txBody>
+      </p:sp>
+      <p:sp>
+        <p:nvSpPr>
+          <p:cNvPr id="9" name="Freeform 8"/>
+          <p:cNvSpPr/>
+          <p:nvPr/>
+        </p:nvSpPr>
+        <p:spPr>
+          <a:xfrm>
+            <a:off x="9304020" y="2194560"/>
+            <a:ext cx="190195" cy="130759"/>
+          </a:xfrm>
+          <a:custGeom>
+            <a:avLst/>
+            <a:gdLst/>
+            <a:ahLst/>
+            <a:cxnLst/>
+            <a:rect l="l" t="t" r="r" b="b"/>
+            <a:pathLst>
+              <a:path w="190195" h="130759">
+                <a:moveTo>
+                  <a:pt x="59436" y="0"/>
+                </a:moveTo>
+                <a:lnTo>
+                  <a:pt x="0" y="130759"/>
+                </a:lnTo>
+                <a:lnTo>
+                  <a:pt x="190195" y="5943"/>
+                </a:lnTo>
+                <a:close/>
+              </a:path>
+            </a:pathLst>
+          </a:custGeom>
+          <a:solidFill>
+            <a:srgbClr val="93D9C2"/>
+          </a:solidFill>
+          <a:ln w="15240">
+            <a:solidFill>
+              <a:srgbClr val="16211D"/>
+            </a:solidFill>
+          </a:ln>
+          <a:effectLst/>
+        </p:spPr>
+        <p:style>
+          <a:lnRef idx="1">
+            <a:schemeClr val="accent1"/>
+          </a:lnRef>
+          <a:fillRef idx="3">
+            <a:schemeClr val="accent1"/>
+          </a:fillRef>
+          <a:effectRef idx="2">
+            <a:schemeClr val="accent1"/>
+          </a:effectRef>
+          <a:fontRef idx="minor">
+            <a:schemeClr val="lt1"/>
+          </a:fontRef>
+        </p:style>
+        <p:txBody>
+          <a:bodyPr rtlCol="0" anchor="ctr"/>
+          <a:lstStyle/>
+          <a:p>
+            <a:pPr algn="ctr"/>
+          </a:p>
+        </p:txBody>
+      </p:sp>
+      <p:sp>
+        <p:nvSpPr>
+          <p:cNvPr id="37" name="Oval 36"/>
+          <p:cNvSpPr/>
+          <p:nvPr/>
+        </p:nvSpPr>
+        <p:spPr>
+          <a:xfrm>
+            <a:off x="9363456" y="2028139"/>
+            <a:ext cx="59436" cy="59436"/>
+          </a:xfrm>
+          <a:prstGeom prst="ellipse">
+            <a:avLst/>
+          </a:prstGeom>
+          <a:solidFill>
+            <a:srgbClr val="16211D"/>
+          </a:solidFill>
+          <a:ln>
+            <a:noFill/>
+          </a:ln>
+          <a:effectLst/>
+        </p:spPr>
+        <p:style>
+          <a:lnRef idx="1">
+            <a:schemeClr val="accent1"/>
+          </a:lnRef>
+          <a:fillRef idx="3">
+            <a:schemeClr val="accent1"/>
+          </a:fillRef>
+          <a:effectRef idx="2">
+            <a:schemeClr val="accent1"/>
+          </a:effectRef>
+          <a:fontRef idx="minor">
+            <a:schemeClr val="lt1"/>
+          </a:fontRef>
+        </p:style>
+        <p:txBody>
+          <a:bodyPr rtlCol="0" anchor="ctr"/>
+          <a:lstStyle/>
+          <a:p>
+            <a:pPr algn="ctr"/>
+          </a:p>
+        </p:txBody>
+      </p:sp>
+      <p:sp>
+        <p:nvSpPr>
+          <p:cNvPr id="38" name="Oval 37"/>
+          <p:cNvSpPr/>
+          <p:nvPr/>
+        </p:nvSpPr>
+        <p:spPr>
+          <a:xfrm>
+            <a:off x="9494215" y="2028139"/>
+            <a:ext cx="59436" cy="59436"/>
+          </a:xfrm>
+          <a:prstGeom prst="ellipse">
+            <a:avLst/>
+          </a:prstGeom>
+          <a:solidFill>
+            <a:srgbClr val="16211D"/>
+          </a:solidFill>
+          <a:ln>
+            <a:noFill/>
+          </a:ln>
+          <a:effectLst/>
+        </p:spPr>
+        <p:style>
+          <a:lnRef idx="1">
+            <a:schemeClr val="accent1"/>
+          </a:lnRef>
+          <a:fillRef idx="3">
+            <a:schemeClr val="accent1"/>
+          </a:fillRef>
+          <a:effectRef idx="2">
+            <a:schemeClr val="accent1"/>
+          </a:effectRef>
+          <a:fontRef idx="minor">
+            <a:schemeClr val="lt1"/>
+          </a:fontRef>
+        </p:style>
+        <p:txBody>
+          <a:bodyPr rtlCol="0" anchor="ctr"/>
+          <a:lstStyle/>
+          <a:p>
+            <a:pPr algn="ctr"/>
+          </a:p>
+        </p:txBody>
+      </p:sp>
+      <p:sp>
+        <p:nvSpPr>
+          <p:cNvPr id="39" name="Oval 38"/>
+          <p:cNvSpPr/>
+          <p:nvPr/>
+        </p:nvSpPr>
+        <p:spPr>
+          <a:xfrm>
+            <a:off x="9624974" y="2028139"/>
+            <a:ext cx="59436" cy="59436"/>
+          </a:xfrm>
+          <a:prstGeom prst="ellipse">
+            <a:avLst/>
+          </a:prstGeom>
+          <a:solidFill>
+            <a:srgbClr val="16211D"/>
+          </a:solidFill>
+          <a:ln>
+            <a:noFill/>
+          </a:ln>
+          <a:effectLst/>
+        </p:spPr>
+        <p:style>
+          <a:lnRef idx="1">
+            <a:schemeClr val="accent1"/>
+          </a:lnRef>
+          <a:fillRef idx="3">
+            <a:schemeClr val="accent1"/>
+          </a:fillRef>
+          <a:effectRef idx="2">
+            <a:schemeClr val="accent1"/>
+          </a:effectRef>
+          <a:fontRef idx="minor">
+            <a:schemeClr val="lt1"/>
+          </a:fontRef>
+        </p:style>
+        <p:txBody>
+          <a:bodyPr rtlCol="0" anchor="ctr"/>
+          <a:lstStyle/>
+          <a:p>
+            <a:pPr algn="ctr"/>
+          </a:p>
+        </p:txBody>
+      </p:sp>
+      <p:sp>
+        <p:nvSpPr>
+          <p:cNvPr id="40" name="Rounded Rectangle 39"/>
+          <p:cNvSpPr/>
+          <p:nvPr/>
+        </p:nvSpPr>
+        <p:spPr>
+          <a:xfrm>
+            <a:off x="9945928" y="2147011"/>
+            <a:ext cx="511149" cy="261518"/>
+          </a:xfrm>
+          <a:prstGeom prst="roundRect">
+            <a:avLst>
+              <a:gd name="adj" fmla="val 50000"/>
+            </a:avLst>
+          </a:prstGeom>
+          <a:solidFill>
+            <a:srgbClr val="FFFFFF"/>
+          </a:solidFill>
+          <a:ln w="15240">
+            <a:solidFill>
+              <a:srgbClr val="16211D"/>
+            </a:solidFill>
+          </a:ln>
+          <a:effectLst/>
+        </p:spPr>
+        <p:style>
+          <a:lnRef idx="1">
+            <a:schemeClr val="accent1"/>
+          </a:lnRef>
+          <a:fillRef idx="3">
+            <a:schemeClr val="accent1"/>
+          </a:fillRef>
+          <a:effectRef idx="2">
+            <a:schemeClr val="accent1"/>
+          </a:effectRef>
+          <a:fontRef idx="minor">
+            <a:schemeClr val="lt1"/>
+          </a:fontRef>
+        </p:style>
+        <p:txBody>
+          <a:bodyPr rtlCol="0" anchor="ctr"/>
+          <a:lstStyle/>
+          <a:p>
+            <a:pPr algn="ctr"/>
+          </a:p>
+        </p:txBody>
+      </p:sp>
+      <p:sp>
+        <p:nvSpPr>
+          <p:cNvPr id="11" name="Freeform 10"/>
+          <p:cNvSpPr/>
+          <p:nvPr/>
+        </p:nvSpPr>
+        <p:spPr>
+          <a:xfrm>
+            <a:off x="10171785" y="2390698"/>
+            <a:ext cx="130759" cy="130760"/>
+          </a:xfrm>
+          <a:custGeom>
+            <a:avLst/>
+            <a:gdLst/>
+            <a:ahLst/>
+            <a:cxnLst/>
+            <a:rect l="l" t="t" r="r" b="b"/>
+            <a:pathLst>
+              <a:path w="130759" h="130760">
+                <a:moveTo>
+                  <a:pt x="0" y="5944"/>
+                </a:moveTo>
+                <a:lnTo>
+                  <a:pt x="23775" y="130760"/>
+                </a:lnTo>
+                <a:lnTo>
+                  <a:pt x="130759" y="0"/>
+                </a:lnTo>
+                <a:close/>
+              </a:path>
+            </a:pathLst>
+          </a:custGeom>
+          <a:solidFill>
+            <a:srgbClr val="FFFFFF"/>
+          </a:solidFill>
+          <a:ln w="15240">
+            <a:solidFill>
+              <a:srgbClr val="16211D"/>
+            </a:solidFill>
+          </a:ln>
+          <a:effectLst/>
+        </p:spPr>
+        <p:style>
+          <a:lnRef idx="1">
+            <a:schemeClr val="accent1"/>
+          </a:lnRef>
+          <a:fillRef idx="3">
+            <a:schemeClr val="accent1"/>
+          </a:fillRef>
+          <a:effectRef idx="2">
+            <a:schemeClr val="accent1"/>
+          </a:effectRef>
+          <a:fontRef idx="minor">
+            <a:schemeClr val="lt1"/>
+          </a:fontRef>
+        </p:style>
+        <p:txBody>
+          <a:bodyPr rtlCol="0" anchor="ctr"/>
+          <a:lstStyle/>
+          <a:p>
+            <a:pPr algn="ctr"/>
+          </a:p>
+        </p:txBody>
+      </p:sp>
+      <p:cxnSp>
+        <p:nvCxnSpPr>
+          <p:cNvPr id="41" name="Connector 40"/>
+          <p:cNvCxnSpPr/>
+          <p:nvPr/>
+        </p:nvCxnSpPr>
+        <p:spPr>
+          <a:xfrm>
+            <a:off x="10052913" y="2277770"/>
+            <a:ext cx="297180" cy="0"/>
+          </a:xfrm>
+          <a:prstGeom prst="line">
+            <a:avLst/>
+          </a:prstGeom>
+          <a:ln w="23774" cap="rnd">
+            <a:solidFill>
+              <a:srgbClr val="16211D"/>
+            </a:solidFill>
+            <a:round/>
+          </a:ln>
+          <a:effectLst/>
+        </p:spPr>
+        <p:style>
+          <a:lnRef idx="2">
+            <a:schemeClr val="accent1"/>
+          </a:lnRef>
+          <a:fillRef idx="0">
+            <a:schemeClr val="accent1"/>
+          </a:fillRef>
+          <a:effectRef idx="1">
+            <a:schemeClr val="accent1"/>
+          </a:effectRef>
+          <a:fontRef idx="minor">
+            <a:schemeClr val="tx1"/>
+          </a:fontRef>
+        </p:style>
+      </p:cxnSp>
+      <p:sp>
+        <p:nvSpPr>
+          <p:cNvPr id="42" name="Rectangle 41"/>
+          <p:cNvSpPr/>
+          <p:nvPr/>
+        </p:nvSpPr>
+        <p:spPr>
+          <a:xfrm rot="21300000">
+            <a:off x="8808293" y="3808988"/>
+            <a:ext cx="1640433" cy="237744"/>
+          </a:xfrm>
+          <a:prstGeom prst="rect">
+            <a:avLst/>
+          </a:prstGeom>
+          <a:solidFill>
+            <a:srgbClr val="16211D"/>
+          </a:solidFill>
+          <a:ln>
+            <a:noFill/>
+          </a:ln>
+          <a:effectLst/>
+        </p:spPr>
+        <p:style>
+          <a:lnRef idx="1">
+            <a:schemeClr val="accent1"/>
+          </a:lnRef>
+          <a:fillRef idx="3">
+            <a:schemeClr val="accent1"/>
+          </a:fillRef>
+          <a:effectRef idx="2">
+            <a:schemeClr val="accent1"/>
+          </a:effectRef>
+          <a:fontRef idx="minor">
+            <a:schemeClr val="lt1"/>
+          </a:fontRef>
+        </p:style>
+        <p:txBody>
+          <a:bodyPr rtlCol="0" anchor="ctr"/>
+          <a:lstStyle/>
+          <a:p>
+            <a:pPr algn="ctr"/>
+          </a:p>
+        </p:txBody>
+      </p:sp>
+      <p:sp>
+        <p:nvSpPr>
+          <p:cNvPr id="43" name="Rectangle 42"/>
+          <p:cNvSpPr/>
+          <p:nvPr/>
+        </p:nvSpPr>
+        <p:spPr>
+          <a:xfrm rot="21300000">
+            <a:off x="8769659" y="3776571"/>
+            <a:ext cx="1640433" cy="237744"/>
+          </a:xfrm>
+          <a:prstGeom prst="rect">
+            <a:avLst/>
+          </a:prstGeom>
+          <a:solidFill>
+            <a:srgbClr val="FFFFFF"/>
+          </a:solidFill>
+          <a:ln w="15240">
+            <a:solidFill>
+              <a:srgbClr val="16211D"/>
+            </a:solidFill>
+          </a:ln>
+          <a:effectLst/>
+        </p:spPr>
+        <p:style>
+          <a:lnRef idx="1">
+            <a:schemeClr val="accent1"/>
+          </a:lnRef>
+          <a:fillRef idx="3">
+            <a:schemeClr val="accent1"/>
+          </a:fillRef>
+          <a:effectRef idx="2">
+            <a:schemeClr val="accent1"/>
+          </a:effectRef>
+          <a:fontRef idx="minor">
+            <a:schemeClr val="lt1"/>
+          </a:fontRef>
+        </p:style>
+        <p:txBody>
+          <a:bodyPr rtlCol="0" anchor="ctr" wrap="none" lIns="0" rIns="0" tIns="0" bIns="0"/>
+          <a:lstStyle/>
+          <a:p>
+            <a:pPr algn="ctr"/>
+            <a:r>
+              <a:rPr sz="600" b="1" spc="60">
+                <a:solidFill>
+                  <a:srgbClr val="16211D"/>
+                </a:solidFill>
+                <a:latin typeface="Space Mono"/>
+              </a:rPr>
+              <a:t>REAL CONVERSATIONS</a:t>
+            </a:r>
+          </a:p>
+        </p:txBody>
+      </p:sp>
+      <p:sp>
+        <p:nvSpPr>
+          <p:cNvPr id="44" name="Oval 43"/>
+          <p:cNvSpPr/>
+          <p:nvPr/>
+        </p:nvSpPr>
+        <p:spPr>
+          <a:xfrm>
+            <a:off x="1634947" y="4542739"/>
+            <a:ext cx="570585" cy="570585"/>
+          </a:xfrm>
+          <a:prstGeom prst="ellipse">
+            <a:avLst/>
+          </a:prstGeom>
+          <a:solidFill>
+            <a:srgbClr val="93D9C2"/>
+          </a:solidFill>
+          <a:ln w="15240">
+            <a:solidFill>
+              <a:srgbClr val="16211D"/>
+            </a:solidFill>
+          </a:ln>
+          <a:effectLst/>
+        </p:spPr>
+        <p:style>
+          <a:lnRef idx="1">
+            <a:schemeClr val="accent1"/>
+          </a:lnRef>
+          <a:fillRef idx="3">
+            <a:schemeClr val="accent1"/>
+          </a:fillRef>
+          <a:effectRef idx="2">
+            <a:schemeClr val="accent1"/>
+          </a:effectRef>
+          <a:fontRef idx="minor">
+            <a:schemeClr val="lt1"/>
+          </a:fontRef>
+        </p:style>
+        <p:txBody>
+          <a:bodyPr rtlCol="0" anchor="ctr"/>
+          <a:lstStyle/>
+          <a:p>
+            <a:pPr algn="ctr"/>
+          </a:p>
+        </p:txBody>
+      </p:sp>
+      <p:sp>
+        <p:nvSpPr>
+          <p:cNvPr id="45" name="Round Same Side Corner Rectangle 44"/>
+          <p:cNvSpPr/>
+          <p:nvPr/>
+        </p:nvSpPr>
+        <p:spPr>
+          <a:xfrm>
+            <a:off x="1634947" y="5255971"/>
+            <a:ext cx="570585" cy="998524"/>
+          </a:xfrm>
+          <a:prstGeom prst="round2SameRect">
+            <a:avLst>
+              <a:gd name="adj1" fmla="val 100000"/>
+              <a:gd name="adj2" fmla="val 0"/>
+            </a:avLst>
+          </a:prstGeom>
+          <a:blipFill>
+            <a:blip r:embed="rId8"/>
+            <a:tile tx="0" ty="0" sx="100000" sy="100000" flip="none" algn="tl"/>
+          </a:blipFill>
+          <a:ln w="15240">
+            <a:solidFill>
+              <a:srgbClr val="16211D"/>
+            </a:solidFill>
+          </a:ln>
+          <a:effectLst/>
+        </p:spPr>
+        <p:style>
+          <a:lnRef idx="1">
+            <a:schemeClr val="accent1"/>
+          </a:lnRef>
+          <a:fillRef idx="3">
+            <a:schemeClr val="accent1"/>
+          </a:fillRef>
+          <a:effectRef idx="2">
+            <a:schemeClr val="accent1"/>
+          </a:effectRef>
+          <a:fontRef idx="minor">
+            <a:schemeClr val="lt1"/>
+          </a:fontRef>
+        </p:style>
+        <p:txBody>
+          <a:bodyPr rtlCol="0" anchor="ctr"/>
+          <a:lstStyle/>
+          <a:p>
+            <a:pPr algn="ctr"/>
+          </a:p>
+        </p:txBody>
+      </p:sp>
+      <p:sp>
+        <p:nvSpPr>
+          <p:cNvPr id="13" name="Freeform 12"/>
+          <p:cNvSpPr/>
+          <p:nvPr/>
+        </p:nvSpPr>
+        <p:spPr>
+          <a:xfrm>
+            <a:off x="1355598" y="5672023"/>
+            <a:ext cx="564642" cy="523037"/>
+          </a:xfrm>
+          <a:custGeom>
+            <a:avLst/>
+            <a:gdLst/>
+            <a:ahLst/>
+            <a:cxnLst/>
+            <a:rect l="l" t="t" r="r" b="b"/>
+            <a:pathLst>
+              <a:path w="564642" h="523037">
+                <a:moveTo>
+                  <a:pt x="0" y="136703"/>
+                </a:moveTo>
+                <a:lnTo>
+                  <a:pt x="564642" y="0"/>
+                </a:lnTo>
+                <a:lnTo>
+                  <a:pt x="564642" y="404165"/>
+                </a:lnTo>
+                <a:lnTo>
+                  <a:pt x="0" y="523037"/>
+                </a:lnTo>
+                <a:close/>
+              </a:path>
+            </a:pathLst>
+          </a:custGeom>
+          <a:solidFill>
+            <a:srgbClr val="FFFFFF"/>
+          </a:solidFill>
+          <a:ln w="15240">
+            <a:solidFill>
+              <a:srgbClr val="16211D"/>
+            </a:solidFill>
+          </a:ln>
+          <a:effectLst/>
+        </p:spPr>
+        <p:style>
+          <a:lnRef idx="1">
+            <a:schemeClr val="accent1"/>
+          </a:lnRef>
+          <a:fillRef idx="3">
+            <a:schemeClr val="accent1"/>
+          </a:fillRef>
+          <a:effectRef idx="2">
+            <a:schemeClr val="accent1"/>
+          </a:effectRef>
+          <a:fontRef idx="minor">
+            <a:schemeClr val="lt1"/>
+          </a:fontRef>
+        </p:style>
+        <p:txBody>
+          <a:bodyPr rtlCol="0" anchor="ctr"/>
+          <a:lstStyle/>
+          <a:p>
+            <a:pPr algn="ctr"/>
+          </a:p>
+        </p:txBody>
+      </p:sp>
+      <p:sp>
+        <p:nvSpPr>
+          <p:cNvPr id="15" name="Freeform 14"/>
+          <p:cNvSpPr/>
+          <p:nvPr/>
+        </p:nvSpPr>
+        <p:spPr>
+          <a:xfrm>
+            <a:off x="1920240" y="5672023"/>
+            <a:ext cx="564642" cy="523037"/>
+          </a:xfrm>
+          <a:custGeom>
+            <a:avLst/>
+            <a:gdLst/>
+            <a:ahLst/>
+            <a:cxnLst/>
+            <a:rect l="l" t="t" r="r" b="b"/>
+            <a:pathLst>
+              <a:path w="564642" h="523037">
+                <a:moveTo>
+                  <a:pt x="564642" y="136703"/>
+                </a:moveTo>
+                <a:lnTo>
+                  <a:pt x="0" y="0"/>
+                </a:lnTo>
+                <a:lnTo>
+                  <a:pt x="0" y="404165"/>
+                </a:lnTo>
+                <a:lnTo>
+                  <a:pt x="564642" y="523037"/>
+                </a:lnTo>
+                <a:close/>
+              </a:path>
+            </a:pathLst>
+          </a:custGeom>
+          <a:solidFill>
+            <a:srgbClr val="FFFFFF"/>
+          </a:solidFill>
+          <a:ln w="15240">
+            <a:solidFill>
+              <a:srgbClr val="16211D"/>
+            </a:solidFill>
+          </a:ln>
+          <a:effectLst/>
+        </p:spPr>
+        <p:style>
+          <a:lnRef idx="1">
+            <a:schemeClr val="accent1"/>
+          </a:lnRef>
+          <a:fillRef idx="3">
+            <a:schemeClr val="accent1"/>
+          </a:fillRef>
+          <a:effectRef idx="2">
+            <a:schemeClr val="accent1"/>
+          </a:effectRef>
+          <a:fontRef idx="minor">
+            <a:schemeClr val="lt1"/>
+          </a:fontRef>
+        </p:style>
+        <p:txBody>
+          <a:bodyPr rtlCol="0" anchor="ctr"/>
+          <a:lstStyle/>
+          <a:p>
+            <a:pPr algn="ctr"/>
+          </a:p>
+        </p:txBody>
+      </p:sp>
+      <p:cxnSp>
+        <p:nvCxnSpPr>
+          <p:cNvPr id="46" name="Connector 45"/>
+          <p:cNvCxnSpPr/>
+          <p:nvPr/>
+        </p:nvCxnSpPr>
+        <p:spPr>
+          <a:xfrm flipV="1">
+            <a:off x="1456639" y="5808726"/>
+            <a:ext cx="374447" cy="89154"/>
+          </a:xfrm>
+          <a:prstGeom prst="line">
+            <a:avLst/>
+          </a:prstGeom>
+          <a:ln w="17830" cap="rnd">
+            <a:solidFill>
+              <a:srgbClr val="16211D"/>
+            </a:solidFill>
+            <a:round/>
+          </a:ln>
+          <a:effectLst/>
+        </p:spPr>
+        <p:style>
+          <a:lnRef idx="2">
+            <a:schemeClr val="accent1"/>
+          </a:lnRef>
+          <a:fillRef idx="0">
+            <a:schemeClr val="accent1"/>
+          </a:fillRef>
+          <a:effectRef idx="1">
+            <a:schemeClr val="accent1"/>
+          </a:effectRef>
+          <a:fontRef idx="minor">
+            <a:schemeClr val="tx1"/>
+          </a:fontRef>
+        </p:style>
+      </p:cxnSp>
+      <p:cxnSp>
+        <p:nvCxnSpPr>
+          <p:cNvPr id="47" name="Connector 46"/>
+          <p:cNvCxnSpPr/>
+          <p:nvPr/>
+        </p:nvCxnSpPr>
+        <p:spPr>
+          <a:xfrm flipV="1">
+            <a:off x="1456639" y="5927598"/>
+            <a:ext cx="374447" cy="89154"/>
+          </a:xfrm>
+          <a:prstGeom prst="line">
+            <a:avLst/>
+          </a:prstGeom>
+          <a:ln w="17830" cap="rnd">
+            <a:solidFill>
+              <a:srgbClr val="16211D"/>
+            </a:solidFill>
+            <a:round/>
+          </a:ln>
+          <a:effectLst/>
+        </p:spPr>
+        <p:style>
+          <a:lnRef idx="2">
+            <a:schemeClr val="accent1"/>
+          </a:lnRef>
+          <a:fillRef idx="0">
+            <a:schemeClr val="accent1"/>
+          </a:fillRef>
+          <a:effectRef idx="1">
+            <a:schemeClr val="accent1"/>
+          </a:effectRef>
+          <a:fontRef idx="minor">
+            <a:schemeClr val="tx1"/>
+          </a:fontRef>
+        </p:style>
+      </p:cxnSp>
+      <p:cxnSp>
+        <p:nvCxnSpPr>
+          <p:cNvPr id="48" name="Connector 47"/>
+          <p:cNvCxnSpPr/>
+          <p:nvPr/>
+        </p:nvCxnSpPr>
+        <p:spPr>
+          <a:xfrm>
+            <a:off x="2009394" y="5808726"/>
+            <a:ext cx="374446" cy="89154"/>
+          </a:xfrm>
+          <a:prstGeom prst="line">
+            <a:avLst/>
+          </a:prstGeom>
+          <a:ln w="17830" cap="rnd">
+            <a:solidFill>
+              <a:srgbClr val="16211D"/>
+            </a:solidFill>
+            <a:round/>
+          </a:ln>
+          <a:effectLst/>
+        </p:spPr>
+        <p:style>
+          <a:lnRef idx="2">
+            <a:schemeClr val="accent1"/>
+          </a:lnRef>
+          <a:fillRef idx="0">
+            <a:schemeClr val="accent1"/>
+          </a:fillRef>
+          <a:effectRef idx="1">
+            <a:schemeClr val="accent1"/>
+          </a:effectRef>
+          <a:fontRef idx="minor">
+            <a:schemeClr val="tx1"/>
+          </a:fontRef>
+        </p:style>
+      </p:cxnSp>
+      <p:sp>
+        <p:nvSpPr>
+          <p:cNvPr id="49" name="Freeform 48"/>
+          <p:cNvSpPr/>
+          <p:nvPr/>
+        </p:nvSpPr>
+        <p:spPr>
+          <a:xfrm>
+            <a:off x="1195120" y="4798314"/>
+            <a:ext cx="202083" cy="196138"/>
+          </a:xfrm>
+          <a:custGeom>
+            <a:avLst/>
+            <a:gdLst/>
+            <a:ahLst/>
+            <a:cxnLst/>
+            <a:rect l="l" t="t" r="r" b="b"/>
+            <a:pathLst>
+              <a:path w="202083" h="196138">
+                <a:moveTo>
+                  <a:pt x="101042" y="0"/>
+                </a:moveTo>
+                <a:lnTo>
+                  <a:pt x="202083" y="196138"/>
+                </a:lnTo>
+                <a:lnTo>
+                  <a:pt x="0" y="196138"/>
+                </a:lnTo>
+                <a:close/>
+              </a:path>
+            </a:pathLst>
+          </a:custGeom>
+          <a:solidFill>
+            <a:srgbClr val="93D9C2"/>
+          </a:solidFill>
+          <a:ln w="15240">
+            <a:solidFill>
+              <a:srgbClr val="16211D"/>
+            </a:solidFill>
+          </a:ln>
+          <a:effectLst/>
+        </p:spPr>
+        <p:style>
+          <a:lnRef idx="1">
+            <a:schemeClr val="accent1"/>
+          </a:lnRef>
+          <a:fillRef idx="3">
+            <a:schemeClr val="accent1"/>
+          </a:fillRef>
+          <a:effectRef idx="2">
+            <a:schemeClr val="accent1"/>
+          </a:effectRef>
+          <a:fontRef idx="minor">
+            <a:schemeClr val="lt1"/>
+          </a:fontRef>
+        </p:style>
+        <p:txBody>
+          <a:bodyPr rtlCol="0" anchor="ctr"/>
+          <a:lstStyle/>
+          <a:p>
+            <a:pPr algn="ctr"/>
+          </a:p>
+        </p:txBody>
+      </p:sp>
+      <p:sp>
+        <p:nvSpPr>
+          <p:cNvPr id="50" name="Oval 49"/>
+          <p:cNvSpPr/>
+          <p:nvPr/>
+        </p:nvSpPr>
+        <p:spPr>
+          <a:xfrm>
+            <a:off x="1391259" y="4507077"/>
+            <a:ext cx="106984" cy="106984"/>
+          </a:xfrm>
+          <a:prstGeom prst="ellipse">
+            <a:avLst/>
+          </a:prstGeom>
+          <a:solidFill>
+            <a:srgbClr val="16211D"/>
+          </a:solidFill>
+          <a:ln>
+            <a:noFill/>
+          </a:ln>
+          <a:effectLst/>
+        </p:spPr>
+        <p:style>
+          <a:lnRef idx="1">
+            <a:schemeClr val="accent1"/>
+          </a:lnRef>
+          <a:fillRef idx="3">
+            <a:schemeClr val="accent1"/>
+          </a:fillRef>
+          <a:effectRef idx="2">
+            <a:schemeClr val="accent1"/>
+          </a:effectRef>
+          <a:fontRef idx="minor">
+            <a:schemeClr val="lt1"/>
+          </a:fontRef>
+        </p:style>
+        <p:txBody>
+          <a:bodyPr rtlCol="0" anchor="ctr"/>
+          <a:lstStyle/>
+          <a:p>
+            <a:pPr algn="ctr"/>
+          </a:p>
+        </p:txBody>
+      </p:sp>
+      <p:sp>
+        <p:nvSpPr>
+          <p:cNvPr id="51" name="Freeform 50"/>
+          <p:cNvSpPr/>
+          <p:nvPr/>
+        </p:nvSpPr>
+        <p:spPr>
+          <a:xfrm>
+            <a:off x="2443276" y="4590288"/>
+            <a:ext cx="202083" cy="196138"/>
+          </a:xfrm>
+          <a:custGeom>
+            <a:avLst/>
+            <a:gdLst/>
+            <a:ahLst/>
+            <a:cxnLst/>
+            <a:rect l="l" t="t" r="r" b="b"/>
+            <a:pathLst>
+              <a:path w="202083" h="196138">
+                <a:moveTo>
+                  <a:pt x="101042" y="0"/>
+                </a:moveTo>
+                <a:lnTo>
+                  <a:pt x="202083" y="196138"/>
+                </a:lnTo>
+                <a:lnTo>
+                  <a:pt x="0" y="196138"/>
+                </a:lnTo>
+                <a:close/>
+              </a:path>
+            </a:pathLst>
+          </a:custGeom>
+          <a:solidFill>
+            <a:srgbClr val="93D9C2"/>
+          </a:solidFill>
+          <a:ln w="15240">
+            <a:solidFill>
+              <a:srgbClr val="16211D"/>
+            </a:solidFill>
+          </a:ln>
+          <a:effectLst/>
+        </p:spPr>
+        <p:style>
+          <a:lnRef idx="1">
+            <a:schemeClr val="accent1"/>
+          </a:lnRef>
+          <a:fillRef idx="3">
+            <a:schemeClr val="accent1"/>
+          </a:fillRef>
+          <a:effectRef idx="2">
+            <a:schemeClr val="accent1"/>
+          </a:effectRef>
+          <a:fontRef idx="minor">
+            <a:schemeClr val="lt1"/>
+          </a:fontRef>
+        </p:style>
+        <p:txBody>
+          <a:bodyPr rtlCol="0" anchor="ctr"/>
+          <a:lstStyle/>
+          <a:p>
+            <a:pPr algn="ctr"/>
+          </a:p>
+        </p:txBody>
+      </p:sp>
+      <p:sp>
+        <p:nvSpPr>
+          <p:cNvPr id="52" name="Oval 51"/>
+          <p:cNvSpPr/>
+          <p:nvPr/>
+        </p:nvSpPr>
+        <p:spPr>
+          <a:xfrm>
+            <a:off x="2645359" y="4958791"/>
+            <a:ext cx="95097" cy="95097"/>
+          </a:xfrm>
+          <a:prstGeom prst="ellipse">
+            <a:avLst/>
+          </a:prstGeom>
+          <a:solidFill>
+            <a:srgbClr val="FFFFFF"/>
+          </a:solidFill>
+          <a:ln w="15240">
+            <a:solidFill>
+              <a:srgbClr val="16211D"/>
+            </a:solidFill>
+          </a:ln>
+          <a:effectLst/>
+        </p:spPr>
+        <p:style>
+          <a:lnRef idx="1">
+            <a:schemeClr val="accent1"/>
+          </a:lnRef>
+          <a:fillRef idx="3">
+            <a:schemeClr val="accent1"/>
+          </a:fillRef>
+          <a:effectRef idx="2">
+            <a:schemeClr val="accent1"/>
+          </a:effectRef>
+          <a:fontRef idx="minor">
+            <a:schemeClr val="lt1"/>
+          </a:fontRef>
+        </p:style>
+        <p:txBody>
+          <a:bodyPr rtlCol="0" anchor="ctr"/>
+          <a:lstStyle/>
+          <a:p>
+            <a:pPr algn="ctr"/>
+          </a:p>
+        </p:txBody>
+      </p:sp>
+      <p:sp>
+        <p:nvSpPr>
+          <p:cNvPr id="53" name="Rectangle 52"/>
+          <p:cNvSpPr/>
+          <p:nvPr/>
+        </p:nvSpPr>
+        <p:spPr>
+          <a:xfrm rot="21300000">
+            <a:off x="1068415" y="6359227"/>
+            <a:ext cx="1759305" cy="237744"/>
+          </a:xfrm>
+          <a:prstGeom prst="rect">
+            <a:avLst/>
+          </a:prstGeom>
+          <a:solidFill>
+            <a:srgbClr val="16211D"/>
+          </a:solidFill>
+          <a:ln>
+            <a:noFill/>
+          </a:ln>
+          <a:effectLst/>
+        </p:spPr>
+        <p:style>
+          <a:lnRef idx="1">
+            <a:schemeClr val="accent1"/>
+          </a:lnRef>
+          <a:fillRef idx="3">
+            <a:schemeClr val="accent1"/>
+          </a:fillRef>
+          <a:effectRef idx="2">
+            <a:schemeClr val="accent1"/>
+          </a:effectRef>
+          <a:fontRef idx="minor">
+            <a:schemeClr val="lt1"/>
+          </a:fontRef>
+        </p:style>
+        <p:txBody>
+          <a:bodyPr rtlCol="0" anchor="ctr"/>
+          <a:lstStyle/>
+          <a:p>
+            <a:pPr algn="ctr"/>
+          </a:p>
+        </p:txBody>
+      </p:sp>
+      <p:sp>
+        <p:nvSpPr>
+          <p:cNvPr id="54" name="Rectangle 53"/>
+          <p:cNvSpPr/>
+          <p:nvPr/>
+        </p:nvSpPr>
+        <p:spPr>
+          <a:xfrm rot="21300000">
+            <a:off x="1029781" y="6326810"/>
+            <a:ext cx="1759305" cy="237744"/>
+          </a:xfrm>
+          <a:prstGeom prst="rect">
+            <a:avLst/>
+          </a:prstGeom>
+          <a:solidFill>
+            <a:srgbClr val="FFFFFF"/>
+          </a:solidFill>
+          <a:ln w="15240">
+            <a:solidFill>
+              <a:srgbClr val="16211D"/>
+            </a:solidFill>
+          </a:ln>
+          <a:effectLst/>
+        </p:spPr>
+        <p:style>
+          <a:lnRef idx="1">
+            <a:schemeClr val="accent1"/>
+          </a:lnRef>
+          <a:fillRef idx="3">
+            <a:schemeClr val="accent1"/>
+          </a:fillRef>
+          <a:effectRef idx="2">
+            <a:schemeClr val="accent1"/>
+          </a:effectRef>
+          <a:fontRef idx="minor">
+            <a:schemeClr val="lt1"/>
+          </a:fontRef>
+        </p:style>
+        <p:txBody>
+          <a:bodyPr rtlCol="0" anchor="ctr" wrap="none" lIns="0" rIns="0" tIns="0" bIns="0"/>
+          <a:lstStyle/>
+          <a:p>
+            <a:pPr algn="ctr"/>
+            <a:r>
+              <a:rPr sz="600" b="1" spc="60">
+                <a:solidFill>
+                  <a:srgbClr val="16211D"/>
+                </a:solidFill>
+                <a:latin typeface="Space Mono"/>
+              </a:rPr>
+              <a:t>ONCE UPON A WORKPLACE</a:t>
+            </a:r>
+          </a:p>
+        </p:txBody>
+      </p:sp>
+      <p:sp>
+        <p:nvSpPr>
+          <p:cNvPr id="55" name="Oval 54"/>
+          <p:cNvSpPr/>
+          <p:nvPr/>
+        </p:nvSpPr>
+        <p:spPr>
+          <a:xfrm>
+            <a:off x="4857292" y="5244084"/>
+            <a:ext cx="380390" cy="380390"/>
+          </a:xfrm>
+          <a:prstGeom prst="ellipse">
+            <a:avLst/>
+          </a:prstGeom>
+          <a:solidFill>
+            <a:srgbClr val="93D9C2"/>
+          </a:solidFill>
+          <a:ln w="15240">
+            <a:solidFill>
+              <a:srgbClr val="16211D"/>
+            </a:solidFill>
+          </a:ln>
+          <a:effectLst/>
+        </p:spPr>
+        <p:style>
+          <a:lnRef idx="1">
+            <a:schemeClr val="accent1"/>
+          </a:lnRef>
+          <a:fillRef idx="3">
+            <a:schemeClr val="accent1"/>
+          </a:fillRef>
+          <a:effectRef idx="2">
+            <a:schemeClr val="accent1"/>
+          </a:effectRef>
+          <a:fontRef idx="minor">
+            <a:schemeClr val="lt1"/>
+          </a:fontRef>
+        </p:style>
+        <p:txBody>
+          <a:bodyPr rtlCol="0" anchor="ctr"/>
+          <a:lstStyle/>
+          <a:p>
+            <a:pPr algn="ctr"/>
+          </a:p>
+        </p:txBody>
+      </p:sp>
+      <p:sp>
+        <p:nvSpPr>
+          <p:cNvPr id="56" name="Round Same Side Corner Rectangle 55"/>
+          <p:cNvSpPr/>
+          <p:nvPr/>
+        </p:nvSpPr>
+        <p:spPr>
+          <a:xfrm>
+            <a:off x="4845405" y="5636361"/>
+            <a:ext cx="404164" cy="707288"/>
+          </a:xfrm>
+          <a:prstGeom prst="round2SameRect">
+            <a:avLst>
+              <a:gd name="adj1" fmla="val 100000"/>
+              <a:gd name="adj2" fmla="val 0"/>
+            </a:avLst>
+          </a:prstGeom>
+          <a:blipFill>
+            <a:blip r:embed="rId8"/>
+            <a:tile tx="0" ty="0" sx="100000" sy="100000" flip="none" algn="tl"/>
+          </a:blipFill>
+          <a:ln w="15240">
+            <a:solidFill>
+              <a:srgbClr val="16211D"/>
+            </a:solidFill>
+          </a:ln>
+          <a:effectLst/>
+        </p:spPr>
+        <p:style>
+          <a:lnRef idx="1">
+            <a:schemeClr val="accent1"/>
+          </a:lnRef>
+          <a:fillRef idx="3">
+            <a:schemeClr val="accent1"/>
+          </a:fillRef>
+          <a:effectRef idx="2">
+            <a:schemeClr val="accent1"/>
+          </a:effectRef>
+          <a:fontRef idx="minor">
+            <a:schemeClr val="lt1"/>
+          </a:fontRef>
+        </p:style>
+        <p:txBody>
+          <a:bodyPr rtlCol="0" anchor="ctr"/>
+          <a:lstStyle/>
+          <a:p>
+            <a:pPr algn="ctr"/>
+          </a:p>
+        </p:txBody>
+      </p:sp>
+      <p:sp>
+        <p:nvSpPr>
+          <p:cNvPr id="57" name="Oval 56"/>
+          <p:cNvSpPr/>
+          <p:nvPr/>
+        </p:nvSpPr>
+        <p:spPr>
+          <a:xfrm>
+            <a:off x="5517032" y="4566513"/>
+            <a:ext cx="546811" cy="546811"/>
+          </a:xfrm>
+          <a:prstGeom prst="ellipse">
+            <a:avLst/>
+          </a:prstGeom>
+          <a:solidFill>
+            <a:srgbClr val="FFFFFF"/>
+          </a:solidFill>
+          <a:ln w="15240">
+            <a:solidFill>
+              <a:srgbClr val="16211D"/>
+            </a:solidFill>
+          </a:ln>
+          <a:effectLst/>
+        </p:spPr>
+        <p:style>
+          <a:lnRef idx="1">
+            <a:schemeClr val="accent1"/>
+          </a:lnRef>
+          <a:fillRef idx="3">
+            <a:schemeClr val="accent1"/>
+          </a:fillRef>
+          <a:effectRef idx="2">
+            <a:schemeClr val="accent1"/>
+          </a:effectRef>
+          <a:fontRef idx="minor">
+            <a:schemeClr val="lt1"/>
+          </a:fontRef>
+        </p:style>
+        <p:txBody>
+          <a:bodyPr rtlCol="0" anchor="ctr"/>
+          <a:lstStyle/>
+          <a:p>
+            <a:pPr algn="ctr"/>
+          </a:p>
+        </p:txBody>
+      </p:sp>
+      <p:sp>
+        <p:nvSpPr>
+          <p:cNvPr id="58" name="Round Same Side Corner Rectangle 57"/>
+          <p:cNvSpPr/>
+          <p:nvPr/>
+        </p:nvSpPr>
+        <p:spPr>
+          <a:xfrm>
+            <a:off x="5511088" y="5172760"/>
+            <a:ext cx="558698" cy="1170889"/>
+          </a:xfrm>
+          <a:prstGeom prst="round2SameRect">
+            <a:avLst>
+              <a:gd name="adj1" fmla="val 100000"/>
+              <a:gd name="adj2" fmla="val 0"/>
+            </a:avLst>
+          </a:prstGeom>
+          <a:blipFill>
+            <a:blip r:embed="rId8"/>
+            <a:tile tx="0" ty="0" sx="100000" sy="100000" flip="none" algn="tl"/>
+          </a:blipFill>
+          <a:ln w="15240">
+            <a:solidFill>
+              <a:srgbClr val="16211D"/>
+            </a:solidFill>
+          </a:ln>
+          <a:effectLst/>
+        </p:spPr>
+        <p:style>
+          <a:lnRef idx="1">
+            <a:schemeClr val="accent1"/>
+          </a:lnRef>
+          <a:fillRef idx="3">
+            <a:schemeClr val="accent1"/>
+          </a:fillRef>
+          <a:effectRef idx="2">
+            <a:schemeClr val="accent1"/>
+          </a:effectRef>
+          <a:fontRef idx="minor">
+            <a:schemeClr val="lt1"/>
+          </a:fontRef>
+        </p:style>
+        <p:txBody>
+          <a:bodyPr rtlCol="0" anchor="ctr"/>
+          <a:lstStyle/>
+          <a:p>
+            <a:pPr algn="ctr"/>
+          </a:p>
+        </p:txBody>
+      </p:sp>
+      <p:sp>
+        <p:nvSpPr>
+          <p:cNvPr id="59" name="Oval 58"/>
+          <p:cNvSpPr/>
+          <p:nvPr/>
+        </p:nvSpPr>
+        <p:spPr>
+          <a:xfrm>
+            <a:off x="6289700" y="5042001"/>
+            <a:ext cx="427939" cy="427939"/>
+          </a:xfrm>
+          <a:prstGeom prst="ellipse">
+            <a:avLst/>
+          </a:prstGeom>
+          <a:solidFill>
+            <a:srgbClr val="93D9C2"/>
+          </a:solidFill>
+          <a:ln w="15240">
+            <a:solidFill>
+              <a:srgbClr val="16211D"/>
+            </a:solidFill>
+          </a:ln>
+          <a:effectLst/>
+        </p:spPr>
+        <p:style>
+          <a:lnRef idx="1">
+            <a:schemeClr val="accent1"/>
+          </a:lnRef>
+          <a:fillRef idx="3">
+            <a:schemeClr val="accent1"/>
+          </a:fillRef>
+          <a:effectRef idx="2">
+            <a:schemeClr val="accent1"/>
+          </a:effectRef>
+          <a:fontRef idx="minor">
+            <a:schemeClr val="lt1"/>
+          </a:fontRef>
+        </p:style>
+        <p:txBody>
+          <a:bodyPr rtlCol="0" anchor="ctr"/>
+          <a:lstStyle/>
+          <a:p>
+            <a:pPr algn="ctr"/>
+          </a:p>
+        </p:txBody>
+      </p:sp>
+      <p:sp>
+        <p:nvSpPr>
+          <p:cNvPr id="60" name="Freeform 59"/>
+          <p:cNvSpPr/>
+          <p:nvPr/>
+        </p:nvSpPr>
+        <p:spPr>
+          <a:xfrm>
+            <a:off x="6129223" y="5553151"/>
+            <a:ext cx="748893" cy="790499"/>
+          </a:xfrm>
+          <a:custGeom>
+            <a:avLst/>
+            <a:gdLst/>
+            <a:ahLst/>
+            <a:cxnLst/>
+            <a:rect l="l" t="t" r="r" b="b"/>
+            <a:pathLst>
+              <a:path w="748893" h="790499">
+                <a:moveTo>
+                  <a:pt x="374447" y="0"/>
+                </a:moveTo>
+                <a:lnTo>
+                  <a:pt x="748893" y="790499"/>
+                </a:lnTo>
+                <a:lnTo>
+                  <a:pt x="0" y="790499"/>
+                </a:lnTo>
+                <a:close/>
+              </a:path>
+            </a:pathLst>
+          </a:custGeom>
+          <a:solidFill>
+            <a:srgbClr val="16211D"/>
+          </a:solidFill>
+          <a:ln>
+            <a:noFill/>
+          </a:ln>
+          <a:effectLst/>
+        </p:spPr>
+        <p:style>
+          <a:lnRef idx="1">
+            <a:schemeClr val="accent1"/>
+          </a:lnRef>
+          <a:fillRef idx="3">
+            <a:schemeClr val="accent1"/>
+          </a:fillRef>
+          <a:effectRef idx="2">
+            <a:schemeClr val="accent1"/>
+          </a:effectRef>
+          <a:fontRef idx="minor">
+            <a:schemeClr val="lt1"/>
+          </a:fontRef>
+        </p:style>
+        <p:txBody>
+          <a:bodyPr rtlCol="0" anchor="ctr"/>
+          <a:lstStyle/>
+          <a:p>
+            <a:pPr algn="ctr"/>
+          </a:p>
+        </p:txBody>
+      </p:sp>
+      <p:sp>
+        <p:nvSpPr>
+          <p:cNvPr id="61" name="Rectangle 60"/>
+          <p:cNvSpPr/>
+          <p:nvPr/>
+        </p:nvSpPr>
+        <p:spPr>
+          <a:xfrm rot="21360000">
+            <a:off x="5086408" y="6371593"/>
+            <a:ext cx="1402689" cy="237744"/>
+          </a:xfrm>
+          <a:prstGeom prst="rect">
+            <a:avLst/>
+          </a:prstGeom>
+          <a:solidFill>
+            <a:srgbClr val="16211D"/>
+          </a:solidFill>
+          <a:ln>
+            <a:noFill/>
+          </a:ln>
+          <a:effectLst/>
+        </p:spPr>
+        <p:style>
+          <a:lnRef idx="1">
+            <a:schemeClr val="accent1"/>
+          </a:lnRef>
+          <a:fillRef idx="3">
+            <a:schemeClr val="accent1"/>
+          </a:fillRef>
+          <a:effectRef idx="2">
+            <a:schemeClr val="accent1"/>
+          </a:effectRef>
+          <a:fontRef idx="minor">
+            <a:schemeClr val="lt1"/>
+          </a:fontRef>
+        </p:style>
+        <p:txBody>
+          <a:bodyPr rtlCol="0" anchor="ctr"/>
+          <a:lstStyle/>
+          <a:p>
+            <a:pPr algn="ctr"/>
+          </a:p>
+        </p:txBody>
+      </p:sp>
+      <p:sp>
+        <p:nvSpPr>
+          <p:cNvPr id="62" name="Rectangle 61"/>
+          <p:cNvSpPr/>
+          <p:nvPr/>
+        </p:nvSpPr>
+        <p:spPr>
+          <a:xfrm rot="21360000">
+            <a:off x="5048346" y="6338506"/>
+            <a:ext cx="1402689" cy="237744"/>
+          </a:xfrm>
+          <a:prstGeom prst="rect">
+            <a:avLst/>
+          </a:prstGeom>
+          <a:solidFill>
+            <a:srgbClr val="FFFFFF"/>
+          </a:solidFill>
+          <a:ln w="15240">
+            <a:solidFill>
+              <a:srgbClr val="16211D"/>
+            </a:solidFill>
+          </a:ln>
+          <a:effectLst/>
+        </p:spPr>
+        <p:style>
+          <a:lnRef idx="1">
+            <a:schemeClr val="accent1"/>
+          </a:lnRef>
+          <a:fillRef idx="3">
+            <a:schemeClr val="accent1"/>
+          </a:fillRef>
+          <a:effectRef idx="2">
+            <a:schemeClr val="accent1"/>
+          </a:effectRef>
+          <a:fontRef idx="minor">
+            <a:schemeClr val="lt1"/>
+          </a:fontRef>
+        </p:style>
+        <p:txBody>
+          <a:bodyPr rtlCol="0" anchor="ctr" wrap="none" lIns="0" rIns="0" tIns="0" bIns="0"/>
+          <a:lstStyle/>
+          <a:p>
+            <a:pPr algn="ctr"/>
+            <a:r>
+              <a:rPr sz="600" b="1" spc="60">
+                <a:solidFill>
+                  <a:srgbClr val="16211D"/>
+                </a:solidFill>
+                <a:latin typeface="Space Mono"/>
+              </a:rPr>
+              <a:t>THE ENSEMBLE</a:t>
+            </a:r>
+          </a:p>
+        </p:txBody>
+      </p:sp>
+      <p:sp>
+        <p:nvSpPr>
+          <p:cNvPr id="63" name="Oval 62"/>
+          <p:cNvSpPr/>
+          <p:nvPr/>
+        </p:nvSpPr>
+        <p:spPr>
+          <a:xfrm>
+            <a:off x="8876080" y="4756708"/>
+            <a:ext cx="142646" cy="142646"/>
+          </a:xfrm>
+          <a:prstGeom prst="ellipse">
+            <a:avLst/>
+          </a:prstGeom>
+          <a:solidFill>
+            <a:srgbClr val="16211D"/>
+          </a:solidFill>
+          <a:ln>
+            <a:noFill/>
+          </a:ln>
+          <a:effectLst/>
+        </p:spPr>
+        <p:style>
+          <a:lnRef idx="1">
+            <a:schemeClr val="accent1"/>
+          </a:lnRef>
+          <a:fillRef idx="3">
+            <a:schemeClr val="accent1"/>
+          </a:fillRef>
+          <a:effectRef idx="2">
+            <a:schemeClr val="accent1"/>
+          </a:effectRef>
+          <a:fontRef idx="minor">
+            <a:schemeClr val="lt1"/>
+          </a:fontRef>
+        </p:style>
+        <p:txBody>
+          <a:bodyPr rtlCol="0" anchor="ctr"/>
+          <a:lstStyle/>
+          <a:p>
+            <a:pPr algn="ctr"/>
+          </a:p>
+        </p:txBody>
+      </p:sp>
+      <p:cxnSp>
+        <p:nvCxnSpPr>
+          <p:cNvPr id="64" name="Connector 63"/>
+          <p:cNvCxnSpPr/>
+          <p:nvPr/>
+        </p:nvCxnSpPr>
+        <p:spPr>
+          <a:xfrm flipV="1">
+            <a:off x="9018727" y="4483303"/>
+            <a:ext cx="0" cy="344729"/>
+          </a:xfrm>
+          <a:prstGeom prst="line">
+            <a:avLst/>
+          </a:prstGeom>
+          <a:ln w="29718" cap="rnd">
+            <a:solidFill>
+              <a:srgbClr val="16211D"/>
+            </a:solidFill>
+            <a:round/>
+          </a:ln>
+          <a:effectLst/>
+        </p:spPr>
+        <p:style>
+          <a:lnRef idx="2">
+            <a:schemeClr val="accent1"/>
+          </a:lnRef>
+          <a:fillRef idx="0">
+            <a:schemeClr val="accent1"/>
+          </a:fillRef>
+          <a:effectRef idx="1">
+            <a:schemeClr val="accent1"/>
+          </a:effectRef>
+          <a:fontRef idx="minor">
+            <a:schemeClr val="tx1"/>
+          </a:fontRef>
+        </p:style>
+      </p:cxnSp>
+      <p:sp>
+        <p:nvSpPr>
+          <p:cNvPr id="65" name="Freeform 64"/>
+          <p:cNvSpPr/>
+          <p:nvPr/>
+        </p:nvSpPr>
+        <p:spPr>
+          <a:xfrm>
+            <a:off x="9018727" y="4447641"/>
+            <a:ext cx="178308" cy="130759"/>
+          </a:xfrm>
+          <a:custGeom>
+            <a:avLst/>
+            <a:gdLst/>
+            <a:ahLst/>
+            <a:cxnLst/>
+            <a:rect l="l" t="t" r="r" b="b"/>
+            <a:pathLst>
+              <a:path w="178308" h="130759">
+                <a:moveTo>
+                  <a:pt x="0" y="35662"/>
+                </a:moveTo>
+                <a:lnTo>
+                  <a:pt x="106985" y="0"/>
+                </a:lnTo>
+                <a:lnTo>
+                  <a:pt x="166421" y="35662"/>
+                </a:lnTo>
+                <a:lnTo>
+                  <a:pt x="178308" y="130759"/>
+                </a:lnTo>
+              </a:path>
+            </a:pathLst>
+          </a:custGeom>
+          <a:noFill/>
+          <a:ln w="29209">
+            <a:solidFill>
+              <a:srgbClr val="16211D"/>
+            </a:solidFill>
+          </a:ln>
+          <a:effectLst/>
+        </p:spPr>
+        <p:style>
+          <a:lnRef idx="1">
+            <a:schemeClr val="accent1"/>
+          </a:lnRef>
+          <a:fillRef idx="3">
+            <a:schemeClr val="accent1"/>
+          </a:fillRef>
+          <a:effectRef idx="2">
+            <a:schemeClr val="accent1"/>
+          </a:effectRef>
+          <a:fontRef idx="minor">
+            <a:schemeClr val="lt1"/>
+          </a:fontRef>
+        </p:style>
+        <p:txBody>
+          <a:bodyPr rtlCol="0" anchor="ctr"/>
+          <a:lstStyle/>
+          <a:p>
+            <a:pPr algn="ctr"/>
+          </a:p>
+        </p:txBody>
+      </p:sp>
+      <p:sp>
+        <p:nvSpPr>
+          <p:cNvPr id="66" name="Oval 65"/>
+          <p:cNvSpPr/>
+          <p:nvPr/>
+        </p:nvSpPr>
+        <p:spPr>
+          <a:xfrm>
+            <a:off x="9161373" y="5071719"/>
+            <a:ext cx="106984" cy="106984"/>
+          </a:xfrm>
+          <a:prstGeom prst="ellipse">
+            <a:avLst/>
+          </a:prstGeom>
+          <a:solidFill>
+            <a:srgbClr val="93D9C2"/>
+          </a:solidFill>
+          <a:ln w="15240">
+            <a:solidFill>
+              <a:srgbClr val="16211D"/>
+            </a:solidFill>
+          </a:ln>
+          <a:effectLst/>
+        </p:spPr>
+        <p:style>
+          <a:lnRef idx="1">
+            <a:schemeClr val="accent1"/>
+          </a:lnRef>
+          <a:fillRef idx="3">
+            <a:schemeClr val="accent1"/>
+          </a:fillRef>
+          <a:effectRef idx="2">
+            <a:schemeClr val="accent1"/>
+          </a:effectRef>
+          <a:fontRef idx="minor">
+            <a:schemeClr val="lt1"/>
+          </a:fontRef>
+        </p:style>
+        <p:txBody>
+          <a:bodyPr rtlCol="0" anchor="ctr"/>
+          <a:lstStyle/>
+          <a:p>
+            <a:pPr algn="ctr"/>
+          </a:p>
+        </p:txBody>
+      </p:sp>
+      <p:sp>
+        <p:nvSpPr>
+          <p:cNvPr id="67" name="Freeform 66"/>
+          <p:cNvSpPr/>
+          <p:nvPr/>
+        </p:nvSpPr>
+        <p:spPr>
+          <a:xfrm>
+            <a:off x="10201503" y="4530852"/>
+            <a:ext cx="202083" cy="196138"/>
+          </a:xfrm>
+          <a:custGeom>
+            <a:avLst/>
+            <a:gdLst/>
+            <a:ahLst/>
+            <a:cxnLst/>
+            <a:rect l="l" t="t" r="r" b="b"/>
+            <a:pathLst>
+              <a:path w="202083" h="196138">
+                <a:moveTo>
+                  <a:pt x="101041" y="0"/>
+                </a:moveTo>
+                <a:lnTo>
+                  <a:pt x="202083" y="196138"/>
+                </a:lnTo>
+                <a:lnTo>
+                  <a:pt x="0" y="196138"/>
+                </a:lnTo>
+                <a:close/>
+              </a:path>
+            </a:pathLst>
+          </a:custGeom>
+          <a:solidFill>
+            <a:srgbClr val="93D9C2"/>
+          </a:solidFill>
+          <a:ln w="15240">
+            <a:solidFill>
+              <a:srgbClr val="16211D"/>
+            </a:solidFill>
+          </a:ln>
+          <a:effectLst/>
+        </p:spPr>
+        <p:style>
+          <a:lnRef idx="1">
+            <a:schemeClr val="accent1"/>
+          </a:lnRef>
+          <a:fillRef idx="3">
+            <a:schemeClr val="accent1"/>
+          </a:fillRef>
+          <a:effectRef idx="2">
+            <a:schemeClr val="accent1"/>
+          </a:effectRef>
+          <a:fontRef idx="minor">
+            <a:schemeClr val="lt1"/>
+          </a:fontRef>
+        </p:style>
+        <p:txBody>
+          <a:bodyPr rtlCol="0" anchor="ctr"/>
+          <a:lstStyle/>
+          <a:p>
+            <a:pPr algn="ctr"/>
+          </a:p>
+        </p:txBody>
+      </p:sp>
+      <p:sp>
+        <p:nvSpPr>
+          <p:cNvPr id="68" name="Oval 67"/>
+          <p:cNvSpPr/>
+          <p:nvPr/>
+        </p:nvSpPr>
+        <p:spPr>
+          <a:xfrm>
+            <a:off x="9660916" y="4687042"/>
+            <a:ext cx="546811" cy="546811"/>
+          </a:xfrm>
+          <a:prstGeom prst="ellipse">
+            <a:avLst/>
+          </a:prstGeom>
+          <a:solidFill>
+            <a:srgbClr val="93D9C2"/>
+          </a:solidFill>
+          <a:ln w="15240">
+            <a:solidFill>
+              <a:srgbClr val="16211D"/>
+            </a:solidFill>
+          </a:ln>
+          <a:effectLst/>
+        </p:spPr>
+        <p:style>
+          <a:lnRef idx="1">
+            <a:schemeClr val="accent1"/>
+          </a:lnRef>
+          <a:fillRef idx="3">
+            <a:schemeClr val="accent1"/>
+          </a:fillRef>
+          <a:effectRef idx="2">
+            <a:schemeClr val="accent1"/>
+          </a:effectRef>
+          <a:fontRef idx="minor">
+            <a:schemeClr val="lt1"/>
+          </a:fontRef>
+        </p:style>
+        <p:txBody>
+          <a:bodyPr rtlCol="0" anchor="ctr"/>
+          <a:lstStyle/>
+          <a:p>
+            <a:pPr algn="ctr"/>
+          </a:p>
+        </p:txBody>
+      </p:sp>
+      <p:sp>
+        <p:nvSpPr>
+          <p:cNvPr id="69" name="Round Same Side Corner Rectangle 68"/>
+          <p:cNvSpPr/>
+          <p:nvPr/>
+        </p:nvSpPr>
+        <p:spPr>
+          <a:xfrm rot="600000">
+            <a:off x="9512046" y="5298170"/>
+            <a:ext cx="546811" cy="1016355"/>
+          </a:xfrm>
+          <a:prstGeom prst="round2SameRect">
+            <a:avLst>
+              <a:gd name="adj1" fmla="val 100000"/>
+              <a:gd name="adj2" fmla="val 0"/>
+            </a:avLst>
+          </a:prstGeom>
+          <a:blipFill>
+            <a:blip r:embed="rId8"/>
+            <a:tile tx="0" ty="0" sx="100000" sy="100000" flip="none" algn="tl"/>
+          </a:blipFill>
+          <a:ln w="15240">
+            <a:solidFill>
+              <a:srgbClr val="16211D"/>
+            </a:solidFill>
+          </a:ln>
+          <a:effectLst/>
+        </p:spPr>
+        <p:style>
+          <a:lnRef idx="1">
+            <a:schemeClr val="accent1"/>
+          </a:lnRef>
+          <a:fillRef idx="3">
+            <a:schemeClr val="accent1"/>
+          </a:fillRef>
+          <a:effectRef idx="2">
+            <a:schemeClr val="accent1"/>
+          </a:effectRef>
+          <a:fontRef idx="minor">
+            <a:schemeClr val="lt1"/>
+          </a:fontRef>
+        </p:style>
+        <p:txBody>
+          <a:bodyPr rtlCol="0" anchor="ctr"/>
+          <a:lstStyle/>
+          <a:p>
+            <a:pPr algn="ctr"/>
+          </a:p>
+        </p:txBody>
+      </p:sp>
+      <p:cxnSp>
+        <p:nvCxnSpPr>
+          <p:cNvPr id="70" name="Connector 69"/>
+          <p:cNvCxnSpPr/>
+          <p:nvPr/>
+        </p:nvCxnSpPr>
+        <p:spPr>
+          <a:xfrm flipH="1" flipV="1">
+            <a:off x="9330117" y="5306557"/>
+            <a:ext cx="217648" cy="340142"/>
+          </a:xfrm>
+          <a:prstGeom prst="line">
+            <a:avLst/>
+          </a:prstGeom>
+          <a:ln w="35661" cap="rnd">
+            <a:solidFill>
+              <a:srgbClr val="16211D"/>
+            </a:solidFill>
+            <a:round/>
+          </a:ln>
+          <a:effectLst/>
+        </p:spPr>
+        <p:style>
+          <a:lnRef idx="2">
+            <a:schemeClr val="accent1"/>
+          </a:lnRef>
+          <a:fillRef idx="0">
+            <a:schemeClr val="accent1"/>
+          </a:fillRef>
+          <a:effectRef idx="1">
+            <a:schemeClr val="accent1"/>
+          </a:effectRef>
+          <a:fontRef idx="minor">
+            <a:schemeClr val="tx1"/>
+          </a:fontRef>
+        </p:style>
+      </p:cxnSp>
+      <p:cxnSp>
+        <p:nvCxnSpPr>
+          <p:cNvPr id="71" name="Connector 70"/>
+          <p:cNvCxnSpPr/>
+          <p:nvPr/>
+        </p:nvCxnSpPr>
+        <p:spPr>
+          <a:xfrm flipV="1">
+            <a:off x="10062855" y="5550867"/>
+            <a:ext cx="310536" cy="186656"/>
+          </a:xfrm>
+          <a:prstGeom prst="line">
+            <a:avLst/>
+          </a:prstGeom>
+          <a:ln w="35661" cap="rnd">
+            <a:solidFill>
+              <a:srgbClr val="16211D"/>
+            </a:solidFill>
+            <a:round/>
+          </a:ln>
+          <a:effectLst/>
+        </p:spPr>
+        <p:style>
+          <a:lnRef idx="2">
+            <a:schemeClr val="accent1"/>
+          </a:lnRef>
+          <a:fillRef idx="0">
+            <a:schemeClr val="accent1"/>
+          </a:fillRef>
+          <a:effectRef idx="1">
+            <a:schemeClr val="accent1"/>
+          </a:effectRef>
+          <a:fontRef idx="minor">
+            <a:schemeClr val="tx1"/>
+          </a:fontRef>
+        </p:style>
+      </p:cxnSp>
+      <p:sp>
+        <p:nvSpPr>
+          <p:cNvPr id="72" name="Oval 71"/>
+          <p:cNvSpPr/>
+          <p:nvPr/>
+        </p:nvSpPr>
+        <p:spPr>
+          <a:xfrm>
+            <a:off x="9242786" y="5199955"/>
+            <a:ext cx="118872" cy="118872"/>
+          </a:xfrm>
+          <a:prstGeom prst="ellipse">
+            <a:avLst/>
+          </a:prstGeom>
+          <a:solidFill>
+            <a:srgbClr val="FFFFFF"/>
+          </a:solidFill>
+          <a:ln w="15240">
+            <a:solidFill>
+              <a:srgbClr val="16211D"/>
+            </a:solidFill>
+          </a:ln>
+          <a:effectLst/>
+        </p:spPr>
+        <p:style>
+          <a:lnRef idx="1">
+            <a:schemeClr val="accent1"/>
+          </a:lnRef>
+          <a:fillRef idx="3">
+            <a:schemeClr val="accent1"/>
+          </a:fillRef>
+          <a:effectRef idx="2">
+            <a:schemeClr val="accent1"/>
+          </a:effectRef>
+          <a:fontRef idx="minor">
+            <a:schemeClr val="lt1"/>
+          </a:fontRef>
+        </p:style>
+        <p:txBody>
+          <a:bodyPr rtlCol="0" anchor="ctr"/>
+          <a:lstStyle/>
+          <a:p>
+            <a:pPr algn="ctr"/>
+          </a:p>
+        </p:txBody>
+      </p:sp>
+      <p:sp>
+        <p:nvSpPr>
+          <p:cNvPr id="73" name="Oval 72"/>
+          <p:cNvSpPr/>
+          <p:nvPr/>
+        </p:nvSpPr>
+        <p:spPr>
+          <a:xfrm>
+            <a:off x="10356299" y="5456651"/>
+            <a:ext cx="118872" cy="118872"/>
+          </a:xfrm>
+          <a:prstGeom prst="ellipse">
+            <a:avLst/>
+          </a:prstGeom>
+          <a:solidFill>
+            <a:srgbClr val="FFFFFF"/>
+          </a:solidFill>
+          <a:ln w="15240">
+            <a:solidFill>
+              <a:srgbClr val="16211D"/>
+            </a:solidFill>
+          </a:ln>
+          <a:effectLst/>
+        </p:spPr>
+        <p:style>
+          <a:lnRef idx="1">
+            <a:schemeClr val="accent1"/>
+          </a:lnRef>
+          <a:fillRef idx="3">
+            <a:schemeClr val="accent1"/>
+          </a:fillRef>
+          <a:effectRef idx="2">
+            <a:schemeClr val="accent1"/>
+          </a:effectRef>
+          <a:fontRef idx="minor">
+            <a:schemeClr val="lt1"/>
+          </a:fontRef>
+        </p:style>
+        <p:txBody>
+          <a:bodyPr rtlCol="0" anchor="ctr"/>
+          <a:lstStyle/>
+          <a:p>
+            <a:pPr algn="ctr"/>
+          </a:p>
+        </p:txBody>
+      </p:sp>
+      <p:sp>
+        <p:nvSpPr>
+          <p:cNvPr id="74" name="Rectangle 73"/>
+          <p:cNvSpPr/>
+          <p:nvPr/>
+        </p:nvSpPr>
+        <p:spPr>
+          <a:xfrm rot="21240000">
+            <a:off x="8987840" y="6369379"/>
+            <a:ext cx="1283817" cy="237744"/>
+          </a:xfrm>
+          <a:prstGeom prst="rect">
+            <a:avLst/>
+          </a:prstGeom>
+          <a:solidFill>
+            <a:srgbClr val="16211D"/>
+          </a:solidFill>
+          <a:ln>
+            <a:noFill/>
+          </a:ln>
+          <a:effectLst/>
+        </p:spPr>
+        <p:style>
+          <a:lnRef idx="1">
+            <a:schemeClr val="accent1"/>
+          </a:lnRef>
+          <a:fillRef idx="3">
+            <a:schemeClr val="accent1"/>
+          </a:fillRef>
+          <a:effectRef idx="2">
+            <a:schemeClr val="accent1"/>
+          </a:effectRef>
+          <a:fontRef idx="minor">
+            <a:schemeClr val="lt1"/>
+          </a:fontRef>
+        </p:style>
+        <p:txBody>
+          <a:bodyPr rtlCol="0" anchor="ctr"/>
+          <a:lstStyle/>
+          <a:p>
+            <a:pPr algn="ctr"/>
+          </a:p>
+        </p:txBody>
+      </p:sp>
+      <p:sp>
+        <p:nvSpPr>
+          <p:cNvPr id="75" name="Rectangle 74"/>
+          <p:cNvSpPr/>
+          <p:nvPr/>
+        </p:nvSpPr>
+        <p:spPr>
+          <a:xfrm rot="21240000">
+            <a:off x="8948646" y="6337641"/>
+            <a:ext cx="1283817" cy="237744"/>
+          </a:xfrm>
+          <a:prstGeom prst="rect">
+            <a:avLst/>
+          </a:prstGeom>
+          <a:solidFill>
+            <a:srgbClr val="FFFFFF"/>
+          </a:solidFill>
+          <a:ln w="15240">
+            <a:solidFill>
+              <a:srgbClr val="16211D"/>
+            </a:solidFill>
+          </a:ln>
+          <a:effectLst/>
+        </p:spPr>
+        <p:style>
+          <a:lnRef idx="1">
+            <a:schemeClr val="accent1"/>
+          </a:lnRef>
+          <a:fillRef idx="3">
+            <a:schemeClr val="accent1"/>
+          </a:fillRef>
+          <a:effectRef idx="2">
+            <a:schemeClr val="accent1"/>
+          </a:effectRef>
+          <a:fontRef idx="minor">
+            <a:schemeClr val="lt1"/>
+          </a:fontRef>
+        </p:style>
+        <p:txBody>
+          <a:bodyPr rtlCol="0" anchor="ctr" wrap="none" lIns="0" rIns="0" tIns="0" bIns="0"/>
+          <a:lstStyle/>
+          <a:p>
+            <a:pPr algn="ctr"/>
+            <a:r>
+              <a:rPr sz="600" b="1" spc="60">
+                <a:solidFill>
+                  <a:srgbClr val="16211D"/>
+                </a:solidFill>
+                <a:latin typeface="Space Mono"/>
+              </a:rPr>
+              <a:t>ZUMBA O'CLOCK</a:t>
             </a:r>
           </a:p>
         </p:txBody>

</xml_diff>